<commit_message>
feat: implement Task Planner Agent with ReAct goal decomposition, 3-day trip benchmark, and updated PPTX deck
</commit_message>
<xml_diff>
--- a/Techvruk_Agentic_System_Presentation.pptx
+++ b/Techvruk_Agentic_System_Presentation.pptx
@@ -3168,7 +3168,7 @@
               </a:defRPr>
             </a:pPr>
             <a:r>
-              <a:t>TECHVRUK AI CONTEST SUBMISSION • AGENTIC SYSTEM</a:t>
+              <a:t>TECHVRUK AI CONTEST SUBMISSION • TASK PLANNER AGENT</a:t>
             </a:r>
           </a:p>
           <a:p>
@@ -3183,11 +3183,11 @@
               </a:defRPr>
             </a:pPr>
             <a:r>
-              <a:t>Autonomous Customer Support &amp;</a:t>
+              <a:t>Autonomous Task Planner Agent</a:t>
             </a:r>
             <a:br/>
             <a:r>
-              <a:t>Intelligent Escalation Agent</a:t>
+              <a:t>Goal Decomposition &amp; Execution Architecture</a:t>
             </a:r>
           </a:p>
           <a:p>
@@ -3202,11 +3202,11 @@
               </a:defRPr>
             </a:pPr>
             <a:r>
-              <a:t>Demonstrating the Complete ReAct Agentic Cycle: Plan → Act → Observe → Respond</a:t>
+              <a:t>Given an ambiguous goal (e.g. 'plan a 3-day trip'), autonomously decomposes it into phased sub-tasks,</a:t>
             </a:r>
             <a:br/>
             <a:r>
-              <a:t>With Dynamic Multi-Tool Execution &amp; Tier-2 Human Escalation Protocol</a:t>
+              <a:t>computes feasibility, critical path schedules, budget allocations, and contingency safeguards.</a:t>
             </a:r>
           </a:p>
           <a:p>
@@ -3349,7 +3349,7 @@
               </a:defRPr>
             </a:pPr>
             <a:r>
-              <a:t>The Problem: Why Single-Call Chatbots Fail in Enterprise Support</a:t>
+              <a:t>The Problem: Why Unstructured Goals Fail in Single-Call LLMs</a:t>
             </a:r>
           </a:p>
         </p:txBody>
@@ -3406,7 +3406,7 @@
               </a:defRPr>
             </a:pPr>
             <a:r>
-              <a:t>❌ Traditional Support Chatbots</a:t>
+              <a:t>❌ One-Shot LLM Text Generation</a:t>
             </a:r>
           </a:p>
           <a:p>
@@ -3421,7 +3421,7 @@
               </a:defRPr>
             </a:pPr>
             <a:r>
-              <a:t>• Brittle One-Shot Prompts: Output hallucinations without verifying actual database or live inventory records.</a:t>
+              <a:t>• Unstructured Paragraph Dumps: Produces vague essays lacking sequential order, timestamps, or milestone checkpoints.</a:t>
             </a:r>
           </a:p>
           <a:p>
@@ -3436,7 +3436,7 @@
               </a:defRPr>
             </a:pPr>
             <a:r>
-              <a:t>• Static Rule Trees: Inflexible decision trees frustrate customers when non-standard edge cases occur.</a:t>
+              <a:t>• Zero Constraint Verification: Never calculates whether a $1,200 budget or 3-day window can realistically cover the itinerary.</a:t>
             </a:r>
           </a:p>
           <a:p>
@@ -3451,7 +3451,7 @@
               </a:defRPr>
             </a:pPr>
             <a:r>
-              <a:t>• No Autonomous Action: Incapable of calculating date deltas, checking policy constraints, or issuing refunds.</a:t>
+              <a:t>• Blind to Dependency Blockers: Schedules downstream actions before prerequisites are confirmed (e.g. touring before transit).</a:t>
             </a:r>
           </a:p>
           <a:p>
@@ -3466,7 +3466,7 @@
               </a:defRPr>
             </a:pPr>
             <a:r>
-              <a:t>• Blinded to Customer Distress: Fails to detect escalating rage or legal risks that require human intervention.</a:t>
+              <a:t>• No Operational Safeguards: Ignores weather contingencies, booking lead times, and failure points.</a:t>
             </a:r>
           </a:p>
         </p:txBody>
@@ -3523,7 +3523,7 @@
               </a:defRPr>
             </a:pPr>
             <a:r>
-              <a:t>✅ Our Autonomous Agentic Solution</a:t>
+              <a:t>✅ Autonomous Task Planner Solution</a:t>
             </a:r>
           </a:p>
           <a:p>
@@ -3538,7 +3538,7 @@
               </a:defRPr>
             </a:pPr>
             <a:r>
-              <a:t>• Decomposed Multi-Step Planning: Breaks complex user queries into an ordered sequence of discrete subtasks.</a:t>
+              <a:t>• Decomposed Multi-Phase Breakdown: Generates discrete, numbered sub-tasks with duration estimates and explicit deliverables.</a:t>
             </a:r>
           </a:p>
           <a:p>
@@ -3553,7 +3553,7 @@
               </a:defRPr>
             </a:pPr>
             <a:r>
-              <a:t>• Tool-Use &amp; Grounded Execution: Queries live Knowledge Base, checks customer order database, and evaluates policies.</a:t>
+              <a:t>• Feasibility Auditing: Tests timeline and budget limits against domain benchmarks with feasibility scoring (0-100).</a:t>
             </a:r>
           </a:p>
           <a:p>
@@ -3568,7 +3568,7 @@
               </a:defRPr>
             </a:pPr>
             <a:r>
-              <a:t>• State &amp; Context Maintenance: Preserves full scratchpad history (Thoughts, Actions, Observations) across turns.</a:t>
+              <a:t>• Critical Path Analysis: Maps dependency chains (TASK-01 ➔ TASK-02) and highlights bottlenecks.</a:t>
             </a:r>
           </a:p>
           <a:p>
@@ -3583,7 +3583,7 @@
               </a:defRPr>
             </a:pPr>
             <a:r>
-              <a:t>• Deterministic Escalation Protocols: Formulates Tier-2 tickets with urgency and SLA guarantees when human touch is vital.</a:t>
+              <a:t>• Deterministic Risk Mitigation: Injects automated contingency protocols for each identified operational failure point.</a:t>
             </a:r>
           </a:p>
         </p:txBody>
@@ -3786,7 +3786,7 @@
               </a:defRPr>
             </a:pPr>
             <a:r>
-              <a:t>Task Decomposition</a:t>
+              <a:t>Constraint Parsing</a:t>
             </a:r>
           </a:p>
           <a:p>
@@ -3798,7 +3798,7 @@
               </a:defRPr>
             </a:pPr>
             <a:r>
-              <a:t>Extracts user intent, customer entities (Order ID, Email), and formulates ordered subtasks.</a:t>
+              <a:t>Extracts primary goal, numerical duration, budget ceiling, and domain classification.</a:t>
             </a:r>
           </a:p>
         </p:txBody>
@@ -3870,7 +3870,7 @@
               </a:defRPr>
             </a:pPr>
             <a:r>
-              <a:t>Tool Dispatching</a:t>
+              <a:t>Tool Invocations</a:t>
             </a:r>
           </a:p>
           <a:p>
@@ -3882,7 +3882,7 @@
               </a:defRPr>
             </a:pPr>
             <a:r>
-              <a:t>Invokes specialized tools: search_knowledge_base, lookup_customer_order, check_eligibility.</a:t>
+              <a:t>Calls specialized tools: blueprint search, feasibility auditor, subtask decomposer, critical path scheduler.</a:t>
             </a:r>
           </a:p>
         </p:txBody>
@@ -3954,7 +3954,7 @@
               </a:defRPr>
             </a:pPr>
             <a:r>
-              <a:t>Feedback Accumulation</a:t>
+              <a:t>State Scratchpad</a:t>
             </a:r>
           </a:p>
           <a:p>
@@ -3966,7 +3966,7 @@
               </a:defRPr>
             </a:pPr>
             <a:r>
-              <a:t>Captures raw tool results into structured Pydantic AgentState scratchpad memory.</a:t>
+              <a:t>Accumulates structured observations and constraint checks into Pydantic AgentState memory.</a:t>
             </a:r>
           </a:p>
         </p:txBody>
@@ -4038,7 +4038,7 @@
               </a:defRPr>
             </a:pPr>
             <a:r>
-              <a:t>Resolution / Escalation</a:t>
+              <a:t>Master Plan Synthesis</a:t>
             </a:r>
           </a:p>
           <a:p>
@@ -4050,7 +4050,7 @@
               </a:defRPr>
             </a:pPr>
             <a:r>
-              <a:t>Processes refund autonomously or triggers Tier-2 Human Escalation with SLA tracking.</a:t>
+              <a:t>Compiles phase matrix, milestone timeline, budget breakdown, and persists plan with Plan ID.</a:t>
             </a:r>
           </a:p>
         </p:txBody>
@@ -4146,7 +4146,7 @@
               </a:defRPr>
             </a:pPr>
             <a:r>
-              <a:t>03 / CAPABILITIES &amp; SAFETY</a:t>
+              <a:t>03 / TOOL SUITE &amp; BENCHMARKS</a:t>
             </a:r>
           </a:p>
         </p:txBody>
@@ -4181,7 +4181,7 @@
               </a:defRPr>
             </a:pPr>
             <a:r>
-              <a:t>Autonomous Tool Suite &amp; Multi-Tier Escalation Safeguards</a:t>
+              <a:t>Autonomous Tool Suite &amp; 3-Day Trip Execution Showcase</a:t>
             </a:r>
           </a:p>
         </p:txBody>
@@ -4238,7 +4238,7 @@
               </a:defRPr>
             </a:pPr>
             <a:r>
-              <a:t>🛠️ The 6-Tool Autonomous Ecosystem</a:t>
+              <a:t>🛠️ Autonomous Planning Tools</a:t>
             </a:r>
           </a:p>
           <a:p>
@@ -4253,7 +4253,7 @@
               </a:defRPr>
             </a:pPr>
             <a:r>
-              <a:t>• search_knowledge_base: BM25 relevance ranking over return &amp; warranty policies.</a:t>
+              <a:t>• search_domain_blueprints: Retrieves domain blueprints and milestone phases.</a:t>
             </a:r>
           </a:p>
           <a:p>
@@ -4268,7 +4268,7 @@
               </a:defRPr>
             </a:pPr>
             <a:r>
-              <a:t>• lookup_customer_order: Fetches real-time status, courier tracking, and item details.</a:t>
+              <a:t>• analyze_goal_feasibility: Tests timeline feasibility and resource limits.</a:t>
             </a:r>
           </a:p>
           <a:p>
@@ -4283,7 +4283,7 @@
               </a:defRPr>
             </a:pPr>
             <a:r>
-              <a:t>• check_refund_eligibility: Verifies delivery dates against 30-day return policy.</a:t>
+              <a:t>• decompose_into_subtasks: Generates phase-aligned, numbered sub-tasks with deliverables.</a:t>
             </a:r>
           </a:p>
           <a:p>
@@ -4298,7 +4298,7 @@
               </a:defRPr>
             </a:pPr>
             <a:r>
-              <a:t>• process_refund: Autonomous ledger crediting with transaction reference generation.</a:t>
+              <a:t>• calculate_schedule_and_critical_path: Derives sequential critical path and milestone checkpoints.</a:t>
             </a:r>
           </a:p>
           <a:p>
@@ -4313,7 +4313,7 @@
               </a:defRPr>
             </a:pPr>
             <a:r>
-              <a:t>• escalate_to_human: Routes priority incident packet to Tier-2 specialist.</a:t>
+              <a:t>• assess_risks_and_mitigations: Identifies failure modes and injects contingency safeguards.</a:t>
             </a:r>
           </a:p>
           <a:p>
@@ -4328,7 +4328,7 @@
               </a:defRPr>
             </a:pPr>
             <a:r>
-              <a:t>• log_support_ticket: Persistent CRM interaction archiving.</a:t>
+              <a:t>• export_structured_plan: Persists compiled master plan into permanent JSON records.</a:t>
             </a:r>
           </a:p>
         </p:txBody>
@@ -4352,7 +4352,7 @@
           </a:solidFill>
           <a:ln>
             <a:solidFill>
-              <a:srgbClr val="F59E0B"/>
+              <a:srgbClr val="4ADE80"/>
             </a:solidFill>
           </a:ln>
         </p:spPr>
@@ -4380,18 +4380,18 @@
               </a:spcAft>
               <a:defRPr sz="1800" b="1">
                 <a:solidFill>
-                  <a:srgbClr val="FBBF24"/>
-                </a:solidFill>
-              </a:defRPr>
-            </a:pPr>
-            <a:r>
-              <a:t>🛡️ When Does The Agent Escalate?</a:t>
+                  <a:srgbClr val="4ADE80"/>
+                </a:solidFill>
+              </a:defRPr>
+            </a:pPr>
+            <a:r>
+              <a:t>🌸 Benchmark: 'Plan a 3-Day Trip to Tokyo'</a:t>
             </a:r>
           </a:p>
           <a:p>
             <a:pPr>
               <a:spcAft>
-                <a:spcPts val="800"/>
+                <a:spcPts val="600"/>
               </a:spcAft>
               <a:defRPr sz="1200">
                 <a:solidFill>
@@ -4400,13 +4400,13 @@
               </a:defRPr>
             </a:pPr>
             <a:r>
-              <a:t>• Sentiment &amp; Tone Analysis: Detects angry, distressed, or legally aggressive language and bypasses bot loop.</a:t>
+              <a:t>• Input Goal: 'Plan a 3-day cultural &amp; culinary trip to Tokyo for 2 people on a $1,200 budget.'</a:t>
             </a:r>
           </a:p>
           <a:p>
             <a:pPr>
               <a:spcAft>
-                <a:spcPts val="800"/>
+                <a:spcPts val="600"/>
               </a:spcAft>
               <a:defRPr sz="1200">
                 <a:solidFill>
@@ -4415,13 +4415,13 @@
               </a:defRPr>
             </a:pPr>
             <a:r>
-              <a:t>• High-Value Financial Thresholds: Orders exceeding $500 with courier delays route to human supervisors.</a:t>
+              <a:t>• Phase 1 Logistics: Lodging reservation, flight transfers, local eSIM data, and IC transit card pre-orders.</a:t>
             </a:r>
           </a:p>
           <a:p>
             <a:pPr>
               <a:spcAft>
-                <a:spcPts val="800"/>
+                <a:spcPts val="600"/>
               </a:spcAft>
               <a:defRPr sz="1200">
                 <a:solidFill>
@@ -4430,13 +4430,13 @@
               </a:defRPr>
             </a:pPr>
             <a:r>
-              <a:t>• Policy Exceptions &amp; Extenuating Grounds: Expired 30-day returns with claimed hospital/courier fault are queued with incident context.</a:t>
+              <a:t>• Phase 2 Itinerary: Day 1 arrival &amp; orientation walk; Day 2 Asakusa &amp; culinary food tour; Day 3 Meiji Shrine &amp; market shopping.</a:t>
             </a:r>
           </a:p>
           <a:p>
             <a:pPr>
               <a:spcAft>
-                <a:spcPts val="800"/>
+                <a:spcPts val="600"/>
               </a:spcAft>
               <a:defRPr sz="1200">
                 <a:solidFill>
@@ -4445,7 +4445,22 @@
               </a:defRPr>
             </a:pPr>
             <a:r>
-              <a:t>• Zero Information Loss: Full transcript, tool observations, and order ID are packaged in the Tier-2 Ticket.</a:t>
+              <a:t>• Budget Optimization: Allocates 35% lodging ($420), 25% transit ($300), 20% dining ($240), 12% activities ($144), 8% buffer ($96).</a:t>
+            </a:r>
+          </a:p>
+          <a:p>
+            <a:pPr>
+              <a:spcAft>
+                <a:spcPts val="600"/>
+              </a:spcAft>
+              <a:defRPr sz="1200">
+                <a:solidFill>
+                  <a:srgbClr val="F8FAFC"/>
+                </a:solidFill>
+              </a:defRPr>
+            </a:pPr>
+            <a:r>
+              <a:t>• Risk Mitigation: Pre-downloads offline transit maps and schedules open-date vouchers for rainy weather.</a:t>
             </a:r>
           </a:p>
         </p:txBody>
@@ -4576,7 +4591,7 @@
               </a:defRPr>
             </a:pPr>
             <a:r>
-              <a:t>Technology Stack, Test Coverage &amp; Evaluation Summary</a:t>
+              <a:t>Test Coverage, Technology Stack &amp; Contest Compliance</a:t>
             </a:r>
           </a:p>
         </p:txBody>
@@ -4648,7 +4663,7 @@
               </a:defRPr>
             </a:pPr>
             <a:r>
-              <a:t>✔ 100% Automated Test Coverage: 6 comprehensive unit tests validating policy lookup, order verification, 30-day delta calculations, autonomous refunding, and human escalation.</a:t>
+              <a:t>✔ 100% Automated Test Suite: 6 automated unit tests validating blueprint search, feasibility scoring, 3-day subtask decomposition, critical path derivation, risk assessment, and end-to-end plan generation.</a:t>
             </a:r>
           </a:p>
           <a:p>
@@ -4663,7 +4678,7 @@
               </a:defRPr>
             </a:pPr>
             <a:r>
-              <a:t>✔ Dual-Engine Flexibility: Connects to Google Gemini API (gemini-1.5-flash / gemini-2.5-flash) for live LLM reasoning, OR runs with built-in zero-key offline deterministic engine.</a:t>
+              <a:t>✔ Strict Agentic Behavior: Demonstrates true Plan -&gt; Act -&gt; Observe -&gt; Respond workflow with continuous scratchpad telemetry (no single-shot prompt hacks).</a:t>
             </a:r>
           </a:p>
           <a:p>
@@ -4678,7 +4693,7 @@
               </a:defRPr>
             </a:pPr>
             <a:r>
-              <a:t>✔ Fairness &amp; Free-Tier Adherence: Complies fully with contest guidelines prohibiting paid/restricted APIs — requires zero paid tokens for complete evaluation.</a:t>
+              <a:t>✔ Free-Tier &amp; Zero-Key Compliance: Supports Google Gemini API (gemini-1.5-flash) and features a built-in offline simulator engine so judges can run it without API keys.</a:t>
             </a:r>
           </a:p>
           <a:p>
@@ -4693,7 +4708,7 @@
               </a:defRPr>
             </a:pPr>
             <a:r>
-              <a:t>✔ Multi-Modal User Interfaces: Includes interactive CLI with rich trace visualization and a full Streamlit Web UI with live reasoning inspector and 1-click test scenarios.</a:t>
+              <a:t>✔ Dual Operational Interfaces: Interactive Streamlit Web UI with live reasoning inspector and 1-click test scenarios + rich terminal CLI.</a:t>
             </a:r>
           </a:p>
           <a:p>
@@ -4708,7 +4723,7 @@
               </a:defRPr>
             </a:pPr>
             <a:r>
-              <a:t>✔ Audit Trail: Structured CRM logging in JSON guarantees all actions, refund transactions, and human escalations are fully traceable.</a:t>
+              <a:t>✔ Audit Trail: Structured plan export into JSON guarantees every generated plan has a unique Plan ID (PLAN-2026-...) for verifiable execution.</a:t>
             </a:r>
           </a:p>
         </p:txBody>

</xml_diff>

<commit_message>
feat: universal task planner agent for any goal with Gemini red-and-white UI
</commit_message>
<xml_diff>
--- a/Techvruk_Agentic_System_Presentation.pptx
+++ b/Techvruk_Agentic_System_Presentation.pptx
@@ -3107,7 +3107,7 @@
             <a:avLst/>
           </a:prstGeom>
           <a:solidFill>
-            <a:srgbClr val="0F172A"/>
+            <a:srgbClr val="FAFAFC"/>
           </a:solidFill>
           <a:ln>
             <a:noFill/>
@@ -3137,126 +3137,20 @@
       </p:sp>
       <p:sp>
         <p:nvSpPr>
-          <p:cNvPr id="3" name="TextBox 2"/>
-          <p:cNvSpPr txBox="1"/>
+          <p:cNvPr id="3" name="Rectangle 2"/>
+          <p:cNvSpPr/>
           <p:nvPr/>
         </p:nvSpPr>
         <p:spPr>
           <a:xfrm>
-            <a:off x="1097280" y="1645920"/>
-            <a:ext cx="10058400" cy="3657600"/>
-          </a:xfrm>
-          <a:prstGeom prst="rect">
-            <a:avLst/>
-          </a:prstGeom>
-          <a:noFill/>
-        </p:spPr>
-        <p:txBody>
-          <a:bodyPr wrap="square">
-            <a:spAutoFit/>
-          </a:bodyPr>
-          <a:lstStyle/>
-          <a:p>
-            <a:pPr>
-              <a:spcAft>
-                <a:spcPts val="1400"/>
-              </a:spcAft>
-              <a:defRPr sz="1300" b="1">
-                <a:solidFill>
-                  <a:srgbClr val="38BDF8"/>
-                </a:solidFill>
-              </a:defRPr>
-            </a:pPr>
-            <a:r>
-              <a:t>TECHVRUK AI CONTEST SUBMISSION • TASK PLANNER AGENT</a:t>
-            </a:r>
-          </a:p>
-          <a:p>
-            <a:pPr>
-              <a:spcAft>
-                <a:spcPts val="1600"/>
-              </a:spcAft>
-              <a:defRPr sz="3600" b="1">
-                <a:solidFill>
-                  <a:srgbClr val="F8FAFC"/>
-                </a:solidFill>
-              </a:defRPr>
-            </a:pPr>
-            <a:r>
-              <a:t>Autonomous Task Planner Agent</a:t>
-            </a:r>
-            <a:br/>
-            <a:r>
-              <a:t>Goal Decomposition &amp; Execution Architecture</a:t>
-            </a:r>
-          </a:p>
-          <a:p>
-            <a:pPr>
-              <a:spcAft>
-                <a:spcPts val="3200"/>
-              </a:spcAft>
-              <a:defRPr sz="1600">
-                <a:solidFill>
-                  <a:srgbClr val="94A3B8"/>
-                </a:solidFill>
-              </a:defRPr>
-            </a:pPr>
-            <a:r>
-              <a:t>Given an ambiguous goal (e.g. 'plan a 3-day trip'), autonomously decomposes it into phased sub-tasks,</a:t>
-            </a:r>
-            <a:br/>
-            <a:r>
-              <a:t>computes feasibility, critical path schedules, budget allocations, and contingency safeguards.</a:t>
-            </a:r>
-          </a:p>
-          <a:p>
-            <a:pPr>
-              <a:defRPr sz="1400" b="1">
-                <a:solidFill>
-                  <a:srgbClr val="4ADE80"/>
-                </a:solidFill>
-              </a:defRPr>
-            </a:pPr>
-            <a:r>
-              <a:t>Candidate: Anandha Raaman S  |  Stack: Python, Pydantic, Gemini API / Offline Engine, Streamlit</a:t>
-            </a:r>
-          </a:p>
-        </p:txBody>
-      </p:sp>
-    </p:spTree>
-  </p:cSld>
-  <p:clrMapOvr>
-    <a:masterClrMapping/>
-  </p:clrMapOvr>
-</p:sld>
-</file>
-
-<file path=ppt/slides/slide2.xml><?xml version="1.0" encoding="utf-8"?>
-<p:sld xmlns:a="http://schemas.openxmlformats.org/drawingml/2006/main" xmlns:p="http://schemas.openxmlformats.org/presentationml/2006/main" xmlns:r="http://schemas.openxmlformats.org/officeDocument/2006/relationships">
-  <p:cSld>
-    <p:spTree>
-      <p:nvGrpSpPr>
-        <p:cNvPr id="1" name=""/>
-        <p:cNvGrpSpPr/>
-        <p:nvPr/>
-      </p:nvGrpSpPr>
-      <p:grpSpPr/>
-      <p:sp>
-        <p:nvSpPr>
-          <p:cNvPr id="2" name="Rectangle 1"/>
-          <p:cNvSpPr/>
-          <p:nvPr/>
-        </p:nvSpPr>
-        <p:spPr>
-          <a:xfrm>
-            <a:off x="0" y="0"/>
-            <a:ext cx="12191695" cy="6858000"/>
+            <a:off x="1097280" y="1371600"/>
+            <a:ext cx="731520" cy="73152"/>
           </a:xfrm>
           <a:prstGeom prst="rect">
             <a:avLst/>
           </a:prstGeom>
           <a:solidFill>
-            <a:srgbClr val="0F172A"/>
+            <a:srgbClr val="DC2626"/>
           </a:solidFill>
           <a:ln>
             <a:noFill/>
@@ -3286,14 +3180,14 @@
       </p:sp>
       <p:sp>
         <p:nvSpPr>
-          <p:cNvPr id="3" name="TextBox 2"/>
+          <p:cNvPr id="4" name="TextBox 3"/>
           <p:cNvSpPr txBox="1"/>
           <p:nvPr/>
         </p:nvSpPr>
         <p:spPr>
           <a:xfrm>
-            <a:off x="731520" y="457200"/>
-            <a:ext cx="10698480" cy="365760"/>
+            <a:off x="1097280" y="1645920"/>
+            <a:ext cx="10058400" cy="4114800"/>
           </a:xfrm>
           <a:prstGeom prst="rect">
             <a:avLst/>
@@ -3307,283 +3201,67 @@
           <a:lstStyle/>
           <a:p>
             <a:pPr>
-              <a:defRPr sz="1100" b="1">
-                <a:solidFill>
-                  <a:srgbClr val="38BDF8"/>
-                </a:solidFill>
-              </a:defRPr>
-            </a:pPr>
-            <a:r>
-              <a:t>01 / CONTEXT &amp; PROBLEM</a:t>
-            </a:r>
-          </a:p>
-        </p:txBody>
-      </p:sp>
-      <p:sp>
-        <p:nvSpPr>
-          <p:cNvPr id="4" name="TextBox 3"/>
-          <p:cNvSpPr txBox="1"/>
-          <p:nvPr/>
-        </p:nvSpPr>
-        <p:spPr>
-          <a:xfrm>
-            <a:off x="731520" y="731520"/>
-            <a:ext cx="10698480" cy="731520"/>
-          </a:xfrm>
-          <a:prstGeom prst="rect">
-            <a:avLst/>
-          </a:prstGeom>
-          <a:noFill/>
-        </p:spPr>
-        <p:txBody>
-          <a:bodyPr wrap="square">
-            <a:spAutoFit/>
-          </a:bodyPr>
-          <a:lstStyle/>
-          <a:p>
-            <a:pPr>
-              <a:defRPr sz="2600" b="1">
-                <a:solidFill>
-                  <a:srgbClr val="F8FAFC"/>
-                </a:solidFill>
-              </a:defRPr>
-            </a:pPr>
-            <a:r>
-              <a:t>The Problem: Why Unstructured Goals Fail in Single-Call LLMs</a:t>
-            </a:r>
-          </a:p>
-        </p:txBody>
-      </p:sp>
-      <p:sp>
-        <p:nvSpPr>
-          <p:cNvPr id="5" name="Rounded Rectangle 4"/>
-          <p:cNvSpPr/>
-          <p:nvPr/>
-        </p:nvSpPr>
-        <p:spPr>
-          <a:xfrm>
-            <a:off x="731520" y="1645920"/>
-            <a:ext cx="5120640" cy="4389120"/>
-          </a:xfrm>
-          <a:prstGeom prst="roundRect">
-            <a:avLst/>
-          </a:prstGeom>
-          <a:solidFill>
-            <a:srgbClr val="1E293B"/>
-          </a:solidFill>
-          <a:ln>
-            <a:solidFill>
-              <a:srgbClr val="EF4444"/>
-            </a:solidFill>
-          </a:ln>
-        </p:spPr>
-        <p:style>
-          <a:lnRef idx="1">
-            <a:schemeClr val="accent1"/>
-          </a:lnRef>
-          <a:fillRef idx="3">
-            <a:schemeClr val="accent1"/>
-          </a:fillRef>
-          <a:effectRef idx="2">
-            <a:schemeClr val="accent1"/>
-          </a:effectRef>
-          <a:fontRef idx="minor">
-            <a:schemeClr val="lt1"/>
-          </a:fontRef>
-        </p:style>
-        <p:txBody>
-          <a:bodyPr rtlCol="0" anchor="ctr" wrap="square"/>
-          <a:lstStyle/>
-          <a:p>
-            <a:pPr algn="ctr">
               <a:spcAft>
-                <a:spcPts val="1200"/>
+                <a:spcPts val="1400"/>
               </a:spcAft>
-              <a:defRPr sz="1800" b="1">
-                <a:solidFill>
-                  <a:srgbClr val="F87171"/>
-                </a:solidFill>
-              </a:defRPr>
-            </a:pPr>
-            <a:r>
-              <a:t>❌ One-Shot LLM Text Generation</a:t>
+              <a:defRPr sz="1300" b="1">
+                <a:solidFill>
+                  <a:srgbClr val="DC2626"/>
+                </a:solidFill>
+              </a:defRPr>
+            </a:pPr>
+            <a:r>
+              <a:t>TECHVRUK AI CONTEST SUBMISSION • UNIVERSAL AGENTIC SYSTEM</a:t>
             </a:r>
           </a:p>
           <a:p>
             <a:pPr>
               <a:spcAft>
-                <a:spcPts val="1000"/>
+                <a:spcPts val="1600"/>
               </a:spcAft>
-              <a:defRPr sz="1300">
-                <a:solidFill>
-                  <a:srgbClr val="F8FAFC"/>
-                </a:solidFill>
-              </a:defRPr>
-            </a:pPr>
-            <a:r>
-              <a:t>• Unstructured Paragraph Dumps: Produces vague essays lacking sequential order, timestamps, or milestone checkpoints.</a:t>
+              <a:defRPr sz="3600" b="1">
+                <a:solidFill>
+                  <a:srgbClr val="0F172A"/>
+                </a:solidFill>
+              </a:defRPr>
+            </a:pPr>
+            <a:r>
+              <a:t>Universal Task Planner Agent</a:t>
+            </a:r>
+            <a:br/>
+            <a:r>
+              <a:t>Autonomous Goal Decomposition for ANY Task</a:t>
             </a:r>
           </a:p>
           <a:p>
             <a:pPr>
               <a:spcAft>
-                <a:spcPts val="1000"/>
+                <a:spcPts val="3200"/>
               </a:spcAft>
-              <a:defRPr sz="1300">
-                <a:solidFill>
-                  <a:srgbClr val="F8FAFC"/>
-                </a:solidFill>
-              </a:defRPr>
-            </a:pPr>
-            <a:r>
-              <a:t>• Zero Constraint Verification: Never calculates whether a $1,200 budget or 3-day window can realistically cover the itinerary.</a:t>
+              <a:defRPr sz="1600">
+                <a:solidFill>
+                  <a:srgbClr val="64748B"/>
+                </a:solidFill>
+              </a:defRPr>
+            </a:pPr>
+            <a:r>
+              <a:t>Accepts any arbitrary goal (e.g. travel, software development, exam prep, event planning)</a:t>
+            </a:r>
+            <a:br/>
+            <a:r>
+              <a:t>and autonomously deconstructs it into phased subtasks, critical path schedules, and risk safeguards.</a:t>
             </a:r>
           </a:p>
           <a:p>
             <a:pPr>
-              <a:spcAft>
-                <a:spcPts val="1000"/>
-              </a:spcAft>
-              <a:defRPr sz="1300">
-                <a:solidFill>
-                  <a:srgbClr val="F8FAFC"/>
-                </a:solidFill>
-              </a:defRPr>
-            </a:pPr>
-            <a:r>
-              <a:t>• Blind to Dependency Blockers: Schedules downstream actions before prerequisites are confirmed (e.g. touring before transit).</a:t>
-            </a:r>
-          </a:p>
-          <a:p>
-            <a:pPr>
-              <a:spcAft>
-                <a:spcPts val="1000"/>
-              </a:spcAft>
-              <a:defRPr sz="1300">
-                <a:solidFill>
-                  <a:srgbClr val="F8FAFC"/>
-                </a:solidFill>
-              </a:defRPr>
-            </a:pPr>
-            <a:r>
-              <a:t>• No Operational Safeguards: Ignores weather contingencies, booking lead times, and failure points.</a:t>
-            </a:r>
-          </a:p>
-        </p:txBody>
-      </p:sp>
-      <p:sp>
-        <p:nvSpPr>
-          <p:cNvPr id="6" name="Rounded Rectangle 5"/>
-          <p:cNvSpPr/>
-          <p:nvPr/>
-        </p:nvSpPr>
-        <p:spPr>
-          <a:xfrm>
-            <a:off x="6217920" y="1645920"/>
-            <a:ext cx="5212080" cy="4389120"/>
-          </a:xfrm>
-          <a:prstGeom prst="roundRect">
-            <a:avLst/>
-          </a:prstGeom>
-          <a:solidFill>
-            <a:srgbClr val="1E293B"/>
-          </a:solidFill>
-          <a:ln>
-            <a:solidFill>
-              <a:srgbClr val="4ADE80"/>
-            </a:solidFill>
-          </a:ln>
-        </p:spPr>
-        <p:style>
-          <a:lnRef idx="1">
-            <a:schemeClr val="accent1"/>
-          </a:lnRef>
-          <a:fillRef idx="3">
-            <a:schemeClr val="accent1"/>
-          </a:fillRef>
-          <a:effectRef idx="2">
-            <a:schemeClr val="accent1"/>
-          </a:effectRef>
-          <a:fontRef idx="minor">
-            <a:schemeClr val="lt1"/>
-          </a:fontRef>
-        </p:style>
-        <p:txBody>
-          <a:bodyPr rtlCol="0" anchor="ctr" wrap="square"/>
-          <a:lstStyle/>
-          <a:p>
-            <a:pPr algn="ctr">
-              <a:spcAft>
-                <a:spcPts val="1200"/>
-              </a:spcAft>
-              <a:defRPr sz="1800" b="1">
-                <a:solidFill>
-                  <a:srgbClr val="4ADE80"/>
-                </a:solidFill>
-              </a:defRPr>
-            </a:pPr>
-            <a:r>
-              <a:t>✅ Autonomous Task Planner Solution</a:t>
-            </a:r>
-          </a:p>
-          <a:p>
-            <a:pPr>
-              <a:spcAft>
-                <a:spcPts val="1000"/>
-              </a:spcAft>
-              <a:defRPr sz="1300">
-                <a:solidFill>
-                  <a:srgbClr val="F8FAFC"/>
-                </a:solidFill>
-              </a:defRPr>
-            </a:pPr>
-            <a:r>
-              <a:t>• Decomposed Multi-Phase Breakdown: Generates discrete, numbered sub-tasks with duration estimates and explicit deliverables.</a:t>
-            </a:r>
-          </a:p>
-          <a:p>
-            <a:pPr>
-              <a:spcAft>
-                <a:spcPts val="1000"/>
-              </a:spcAft>
-              <a:defRPr sz="1300">
-                <a:solidFill>
-                  <a:srgbClr val="F8FAFC"/>
-                </a:solidFill>
-              </a:defRPr>
-            </a:pPr>
-            <a:r>
-              <a:t>• Feasibility Auditing: Tests timeline and budget limits against domain benchmarks with feasibility scoring (0-100).</a:t>
-            </a:r>
-          </a:p>
-          <a:p>
-            <a:pPr>
-              <a:spcAft>
-                <a:spcPts val="1000"/>
-              </a:spcAft>
-              <a:defRPr sz="1300">
-                <a:solidFill>
-                  <a:srgbClr val="F8FAFC"/>
-                </a:solidFill>
-              </a:defRPr>
-            </a:pPr>
-            <a:r>
-              <a:t>• Critical Path Analysis: Maps dependency chains (TASK-01 ➔ TASK-02) and highlights bottlenecks.</a:t>
-            </a:r>
-          </a:p>
-          <a:p>
-            <a:pPr>
-              <a:spcAft>
-                <a:spcPts val="1000"/>
-              </a:spcAft>
-              <a:defRPr sz="1300">
-                <a:solidFill>
-                  <a:srgbClr val="F8FAFC"/>
-                </a:solidFill>
-              </a:defRPr>
-            </a:pPr>
-            <a:r>
-              <a:t>• Deterministic Risk Mitigation: Injects automated contingency protocols for each identified operational failure point.</a:t>
+              <a:defRPr sz="1400" b="1">
+                <a:solidFill>
+                  <a:srgbClr val="991B1B"/>
+                </a:solidFill>
+              </a:defRPr>
+            </a:pPr>
+            <a:r>
+              <a:t>Candidate: Anandha Raaman S  |  Stack: Python, Pydantic, Gemini API / Offline Engine, Streamlit (Red &amp; White Theme)</a:t>
             </a:r>
           </a:p>
         </p:txBody>
@@ -3596,7 +3274,7 @@
 </p:sld>
 </file>
 
-<file path=ppt/slides/slide3.xml><?xml version="1.0" encoding="utf-8"?>
+<file path=ppt/slides/slide2.xml><?xml version="1.0" encoding="utf-8"?>
 <p:sld xmlns:a="http://schemas.openxmlformats.org/drawingml/2006/main" xmlns:p="http://schemas.openxmlformats.org/presentationml/2006/main" xmlns:r="http://schemas.openxmlformats.org/officeDocument/2006/relationships">
   <p:cSld>
     <p:spTree>
@@ -3621,7 +3299,7 @@
             <a:avLst/>
           </a:prstGeom>
           <a:solidFill>
-            <a:srgbClr val="0F172A"/>
+            <a:srgbClr val="FAFAFC"/>
           </a:solidFill>
           <a:ln>
             <a:noFill/>
@@ -3674,12 +3352,12 @@
             <a:pPr>
               <a:defRPr sz="1100" b="1">
                 <a:solidFill>
-                  <a:srgbClr val="38BDF8"/>
-                </a:solidFill>
-              </a:defRPr>
-            </a:pPr>
-            <a:r>
-              <a:t>02 / ARCHITECTURE &amp; FLOW</a:t>
+                  <a:srgbClr val="DC2626"/>
+                </a:solidFill>
+              </a:defRPr>
+            </a:pPr>
+            <a:r>
+              <a:t>01 / CONTEXT &amp; PROBLEM</a:t>
             </a:r>
           </a:p>
         </p:txBody>
@@ -3709,12 +3387,12 @@
             <a:pPr>
               <a:defRPr sz="2600" b="1">
                 <a:solidFill>
-                  <a:srgbClr val="F8FAFC"/>
-                </a:solidFill>
-              </a:defRPr>
-            </a:pPr>
-            <a:r>
-              <a:t>System Architecture: Plan → Act → Observe → Respond</a:t>
+                  <a:srgbClr val="0F172A"/>
+                </a:solidFill>
+              </a:defRPr>
+            </a:pPr>
+            <a:r>
+              <a:t>The Problem: Why Unstructured Goals Fail in One-Shot Prompting</a:t>
             </a:r>
           </a:p>
         </p:txBody>
@@ -3728,17 +3406,17 @@
         <p:spPr>
           <a:xfrm>
             <a:off x="731520" y="1645920"/>
-            <a:ext cx="2560320" cy="4389120"/>
+            <a:ext cx="5120640" cy="4389120"/>
           </a:xfrm>
           <a:prstGeom prst="roundRect">
             <a:avLst/>
           </a:prstGeom>
           <a:solidFill>
-            <a:srgbClr val="1E293B"/>
+            <a:srgbClr val="FFFFFF"/>
           </a:solidFill>
           <a:ln>
             <a:solidFill>
-              <a:srgbClr val="38BDF8"/>
+              <a:srgbClr val="DC2626"/>
             </a:solidFill>
           </a:ln>
         </p:spPr>
@@ -3762,16 +3440,16 @@
           <a:p>
             <a:pPr algn="ctr">
               <a:spcAft>
-                <a:spcPts val="600"/>
+                <a:spcPts val="1200"/>
               </a:spcAft>
-              <a:defRPr sz="1600" b="1">
-                <a:solidFill>
-                  <a:srgbClr val="38BDF8"/>
-                </a:solidFill>
-              </a:defRPr>
-            </a:pPr>
-            <a:r>
-              <a:t>1. PLAN</a:t>
+              <a:defRPr sz="1800" b="1">
+                <a:solidFill>
+                  <a:srgbClr val="DC2626"/>
+                </a:solidFill>
+              </a:defRPr>
+            </a:pPr>
+            <a:r>
+              <a:t>❌ One-Shot LLM Text Generation</a:t>
             </a:r>
           </a:p>
           <a:p>
@@ -3779,26 +3457,59 @@
               <a:spcAft>
                 <a:spcPts val="1000"/>
               </a:spcAft>
-              <a:defRPr sz="1300" b="1">
-                <a:solidFill>
-                  <a:srgbClr val="F8FAFC"/>
-                </a:solidFill>
-              </a:defRPr>
-            </a:pPr>
-            <a:r>
-              <a:t>Constraint Parsing</a:t>
+              <a:defRPr sz="1300">
+                <a:solidFill>
+                  <a:srgbClr val="0F172A"/>
+                </a:solidFill>
+              </a:defRPr>
+            </a:pPr>
+            <a:r>
+              <a:t>• Unstructured Paragraph Dumps: Produces vague essays lacking sequential order, timestamps, or milestone checkpoints.</a:t>
             </a:r>
           </a:p>
           <a:p>
             <a:pPr>
-              <a:defRPr sz="1200">
-                <a:solidFill>
-                  <a:srgbClr val="94A3B8"/>
-                </a:solidFill>
-              </a:defRPr>
-            </a:pPr>
-            <a:r>
-              <a:t>Extracts primary goal, numerical duration, budget ceiling, and domain classification.</a:t>
+              <a:spcAft>
+                <a:spcPts val="1000"/>
+              </a:spcAft>
+              <a:defRPr sz="1300">
+                <a:solidFill>
+                  <a:srgbClr val="0F172A"/>
+                </a:solidFill>
+              </a:defRPr>
+            </a:pPr>
+            <a:r>
+              <a:t>• Zero Constraint Verification: Never calculates whether a stated budget or timeline can realistically cover execution.</a:t>
+            </a:r>
+          </a:p>
+          <a:p>
+            <a:pPr>
+              <a:spcAft>
+                <a:spcPts val="1000"/>
+              </a:spcAft>
+              <a:defRPr sz="1300">
+                <a:solidFill>
+                  <a:srgbClr val="0F172A"/>
+                </a:solidFill>
+              </a:defRPr>
+            </a:pPr>
+            <a:r>
+              <a:t>• Blind to Dependency Blockers: Schedules downstream actions before prerequisites are confirmed (e.g. touring before transit).</a:t>
+            </a:r>
+          </a:p>
+          <a:p>
+            <a:pPr>
+              <a:spcAft>
+                <a:spcPts val="1000"/>
+              </a:spcAft>
+              <a:defRPr sz="1300">
+                <a:solidFill>
+                  <a:srgbClr val="0F172A"/>
+                </a:solidFill>
+              </a:defRPr>
+            </a:pPr>
+            <a:r>
+              <a:t>• Rigid Static Templates: Brittle bots fail when user input diverges from hardcoded topics.</a:t>
             </a:r>
           </a:p>
         </p:txBody>
@@ -3811,18 +3522,18 @@
         </p:nvSpPr>
         <p:spPr>
           <a:xfrm>
-            <a:off x="3429000" y="1645920"/>
-            <a:ext cx="2560320" cy="4389120"/>
+            <a:off x="6217920" y="1645920"/>
+            <a:ext cx="5212080" cy="4389120"/>
           </a:xfrm>
           <a:prstGeom prst="roundRect">
             <a:avLst/>
           </a:prstGeom>
           <a:solidFill>
-            <a:srgbClr val="1E293B"/>
+            <a:srgbClr val="FFFFFF"/>
           </a:solidFill>
           <a:ln>
             <a:solidFill>
-              <a:srgbClr val="38BDF8"/>
+              <a:srgbClr val="E2E8F0"/>
             </a:solidFill>
           </a:ln>
         </p:spPr>
@@ -3846,16 +3557,16 @@
           <a:p>
             <a:pPr algn="ctr">
               <a:spcAft>
-                <a:spcPts val="600"/>
+                <a:spcPts val="1200"/>
               </a:spcAft>
-              <a:defRPr sz="1600" b="1">
-                <a:solidFill>
-                  <a:srgbClr val="38BDF8"/>
-                </a:solidFill>
-              </a:defRPr>
-            </a:pPr>
-            <a:r>
-              <a:t>2. ACT</a:t>
+              <a:defRPr sz="1800" b="1">
+                <a:solidFill>
+                  <a:srgbClr val="991B1B"/>
+                </a:solidFill>
+              </a:defRPr>
+            </a:pPr>
+            <a:r>
+              <a:t>✅ Universal Task Planner Solution</a:t>
             </a:r>
           </a:p>
           <a:p>
@@ -3863,83 +3574,14 @@
               <a:spcAft>
                 <a:spcPts val="1000"/>
               </a:spcAft>
-              <a:defRPr sz="1300" b="1">
-                <a:solidFill>
-                  <a:srgbClr val="F8FAFC"/>
-                </a:solidFill>
-              </a:defRPr>
-            </a:pPr>
-            <a:r>
-              <a:t>Tool Invocations</a:t>
-            </a:r>
-          </a:p>
-          <a:p>
-            <a:pPr>
-              <a:defRPr sz="1200">
-                <a:solidFill>
-                  <a:srgbClr val="94A3B8"/>
-                </a:solidFill>
-              </a:defRPr>
-            </a:pPr>
-            <a:r>
-              <a:t>Calls specialized tools: blueprint search, feasibility auditor, subtask decomposer, critical path scheduler.</a:t>
-            </a:r>
-          </a:p>
-        </p:txBody>
-      </p:sp>
-      <p:sp>
-        <p:nvSpPr>
-          <p:cNvPr id="7" name="Rounded Rectangle 6"/>
-          <p:cNvSpPr/>
-          <p:nvPr/>
-        </p:nvSpPr>
-        <p:spPr>
-          <a:xfrm>
-            <a:off x="6126480" y="1645920"/>
-            <a:ext cx="2560320" cy="4389120"/>
-          </a:xfrm>
-          <a:prstGeom prst="roundRect">
-            <a:avLst/>
-          </a:prstGeom>
-          <a:solidFill>
-            <a:srgbClr val="1E293B"/>
-          </a:solidFill>
-          <a:ln>
-            <a:solidFill>
-              <a:srgbClr val="38BDF8"/>
-            </a:solidFill>
-          </a:ln>
-        </p:spPr>
-        <p:style>
-          <a:lnRef idx="1">
-            <a:schemeClr val="accent1"/>
-          </a:lnRef>
-          <a:fillRef idx="3">
-            <a:schemeClr val="accent1"/>
-          </a:fillRef>
-          <a:effectRef idx="2">
-            <a:schemeClr val="accent1"/>
-          </a:effectRef>
-          <a:fontRef idx="minor">
-            <a:schemeClr val="lt1"/>
-          </a:fontRef>
-        </p:style>
-        <p:txBody>
-          <a:bodyPr rtlCol="0" anchor="ctr" wrap="square"/>
-          <a:lstStyle/>
-          <a:p>
-            <a:pPr algn="ctr">
-              <a:spcAft>
-                <a:spcPts val="600"/>
-              </a:spcAft>
-              <a:defRPr sz="1600" b="1">
-                <a:solidFill>
-                  <a:srgbClr val="38BDF8"/>
-                </a:solidFill>
-              </a:defRPr>
-            </a:pPr>
-            <a:r>
-              <a:t>3. OBSERVE</a:t>
+              <a:defRPr sz="1300">
+                <a:solidFill>
+                  <a:srgbClr val="0F172A"/>
+                </a:solidFill>
+              </a:defRPr>
+            </a:pPr>
+            <a:r>
+              <a:t>• Universal Goal Deconstruction: Dynamically analyzes ANY task or prompt without being restricted to pre-baked plans.</a:t>
             </a:r>
           </a:p>
           <a:p>
@@ -3947,83 +3589,14 @@
               <a:spcAft>
                 <a:spcPts val="1000"/>
               </a:spcAft>
-              <a:defRPr sz="1300" b="1">
-                <a:solidFill>
-                  <a:srgbClr val="F8FAFC"/>
-                </a:solidFill>
-              </a:defRPr>
-            </a:pPr>
-            <a:r>
-              <a:t>State Scratchpad</a:t>
-            </a:r>
-          </a:p>
-          <a:p>
-            <a:pPr>
-              <a:defRPr sz="1200">
-                <a:solidFill>
-                  <a:srgbClr val="94A3B8"/>
-                </a:solidFill>
-              </a:defRPr>
-            </a:pPr>
-            <a:r>
-              <a:t>Accumulates structured observations and constraint checks into Pydantic AgentState memory.</a:t>
-            </a:r>
-          </a:p>
-        </p:txBody>
-      </p:sp>
-      <p:sp>
-        <p:nvSpPr>
-          <p:cNvPr id="8" name="Rounded Rectangle 7"/>
-          <p:cNvSpPr/>
-          <p:nvPr/>
-        </p:nvSpPr>
-        <p:spPr>
-          <a:xfrm>
-            <a:off x="8823960" y="1645920"/>
-            <a:ext cx="2560320" cy="4389120"/>
-          </a:xfrm>
-          <a:prstGeom prst="roundRect">
-            <a:avLst/>
-          </a:prstGeom>
-          <a:solidFill>
-            <a:srgbClr val="1E293B"/>
-          </a:solidFill>
-          <a:ln>
-            <a:solidFill>
-              <a:srgbClr val="4ADE80"/>
-            </a:solidFill>
-          </a:ln>
-        </p:spPr>
-        <p:style>
-          <a:lnRef idx="1">
-            <a:schemeClr val="accent1"/>
-          </a:lnRef>
-          <a:fillRef idx="3">
-            <a:schemeClr val="accent1"/>
-          </a:fillRef>
-          <a:effectRef idx="2">
-            <a:schemeClr val="accent1"/>
-          </a:effectRef>
-          <a:fontRef idx="minor">
-            <a:schemeClr val="lt1"/>
-          </a:fontRef>
-        </p:style>
-        <p:txBody>
-          <a:bodyPr rtlCol="0" anchor="ctr" wrap="square"/>
-          <a:lstStyle/>
-          <a:p>
-            <a:pPr algn="ctr">
-              <a:spcAft>
-                <a:spcPts val="600"/>
-              </a:spcAft>
-              <a:defRPr sz="1600" b="1">
-                <a:solidFill>
-                  <a:srgbClr val="4ADE80"/>
-                </a:solidFill>
-              </a:defRPr>
-            </a:pPr>
-            <a:r>
-              <a:t>4. RESPOND</a:t>
+              <a:defRPr sz="1300">
+                <a:solidFill>
+                  <a:srgbClr val="0F172A"/>
+                </a:solidFill>
+              </a:defRPr>
+            </a:pPr>
+            <a:r>
+              <a:t>• Phased Sub-Task Matrix: Generates discrete, numbered subtasks with duration estimates and explicit deliverables.</a:t>
             </a:r>
           </a:p>
           <a:p>
@@ -4031,26 +3604,29 @@
               <a:spcAft>
                 <a:spcPts val="1000"/>
               </a:spcAft>
-              <a:defRPr sz="1300" b="1">
-                <a:solidFill>
-                  <a:srgbClr val="F8FAFC"/>
-                </a:solidFill>
-              </a:defRPr>
-            </a:pPr>
-            <a:r>
-              <a:t>Master Plan Synthesis</a:t>
+              <a:defRPr sz="1300">
+                <a:solidFill>
+                  <a:srgbClr val="0F172A"/>
+                </a:solidFill>
+              </a:defRPr>
+            </a:pPr>
+            <a:r>
+              <a:t>• Feasibility Auditing: Tests timeline and budget limits against operational benchmarks with feasibility scoring (0-100).</a:t>
             </a:r>
           </a:p>
           <a:p>
             <a:pPr>
-              <a:defRPr sz="1200">
-                <a:solidFill>
-                  <a:srgbClr val="94A3B8"/>
-                </a:solidFill>
-              </a:defRPr>
-            </a:pPr>
-            <a:r>
-              <a:t>Compiles phase matrix, milestone timeline, budget breakdown, and persists plan with Plan ID.</a:t>
+              <a:spcAft>
+                <a:spcPts val="1000"/>
+              </a:spcAft>
+              <a:defRPr sz="1300">
+                <a:solidFill>
+                  <a:srgbClr val="0F172A"/>
+                </a:solidFill>
+              </a:defRPr>
+            </a:pPr>
+            <a:r>
+              <a:t>• Critical Path &amp; Risk Guardrails: Maps sequential bottleneck chains and injects automated contingency safeguards.</a:t>
             </a:r>
           </a:p>
         </p:txBody>
@@ -4063,7 +3639,7 @@
 </p:sld>
 </file>
 
-<file path=ppt/slides/slide4.xml><?xml version="1.0" encoding="utf-8"?>
+<file path=ppt/slides/slide3.xml><?xml version="1.0" encoding="utf-8"?>
 <p:sld xmlns:a="http://schemas.openxmlformats.org/drawingml/2006/main" xmlns:p="http://schemas.openxmlformats.org/presentationml/2006/main" xmlns:r="http://schemas.openxmlformats.org/officeDocument/2006/relationships">
   <p:cSld>
     <p:spTree>
@@ -4088,7 +3664,7 @@
             <a:avLst/>
           </a:prstGeom>
           <a:solidFill>
-            <a:srgbClr val="0F172A"/>
+            <a:srgbClr val="FAFAFC"/>
           </a:solidFill>
           <a:ln>
             <a:noFill/>
@@ -4141,12 +3717,12 @@
             <a:pPr>
               <a:defRPr sz="1100" b="1">
                 <a:solidFill>
-                  <a:srgbClr val="38BDF8"/>
-                </a:solidFill>
-              </a:defRPr>
-            </a:pPr>
-            <a:r>
-              <a:t>03 / TOOL SUITE &amp; BENCHMARKS</a:t>
+                  <a:srgbClr val="DC2626"/>
+                </a:solidFill>
+              </a:defRPr>
+            </a:pPr>
+            <a:r>
+              <a:t>02 / ARCHITECTURE &amp; FLOW</a:t>
             </a:r>
           </a:p>
         </p:txBody>
@@ -4176,12 +3752,12 @@
             <a:pPr>
               <a:defRPr sz="2600" b="1">
                 <a:solidFill>
-                  <a:srgbClr val="F8FAFC"/>
-                </a:solidFill>
-              </a:defRPr>
-            </a:pPr>
-            <a:r>
-              <a:t>Autonomous Tool Suite &amp; 3-Day Trip Execution Showcase</a:t>
+                  <a:srgbClr val="0F172A"/>
+                </a:solidFill>
+              </a:defRPr>
+            </a:pPr>
+            <a:r>
+              <a:t>System Architecture: Plan → Act → Observe → Respond</a:t>
             </a:r>
           </a:p>
         </p:txBody>
@@ -4195,17 +3771,17 @@
         <p:spPr>
           <a:xfrm>
             <a:off x="731520" y="1645920"/>
-            <a:ext cx="5120640" cy="4389120"/>
+            <a:ext cx="2560320" cy="4389120"/>
           </a:xfrm>
           <a:prstGeom prst="roundRect">
             <a:avLst/>
           </a:prstGeom>
           <a:solidFill>
-            <a:srgbClr val="1E293B"/>
+            <a:srgbClr val="FFFFFF"/>
           </a:solidFill>
           <a:ln>
             <a:solidFill>
-              <a:srgbClr val="38BDF8"/>
+              <a:srgbClr val="DC2626"/>
             </a:solidFill>
           </a:ln>
         </p:spPr>
@@ -4229,106 +3805,43 @@
           <a:p>
             <a:pPr algn="ctr">
               <a:spcAft>
+                <a:spcPts val="600"/>
+              </a:spcAft>
+              <a:defRPr sz="1600" b="1">
+                <a:solidFill>
+                  <a:srgbClr val="DC2626"/>
+                </a:solidFill>
+              </a:defRPr>
+            </a:pPr>
+            <a:r>
+              <a:t>1. PLAN</a:t>
+            </a:r>
+          </a:p>
+          <a:p>
+            <a:pPr>
+              <a:spcAft>
                 <a:spcPts val="1000"/>
               </a:spcAft>
-              <a:defRPr sz="1800" b="1">
-                <a:solidFill>
-                  <a:srgbClr val="38BDF8"/>
-                </a:solidFill>
-              </a:defRPr>
-            </a:pPr>
-            <a:r>
-              <a:t>🛠️ Autonomous Planning Tools</a:t>
+              <a:defRPr sz="1300" b="1">
+                <a:solidFill>
+                  <a:srgbClr val="0F172A"/>
+                </a:solidFill>
+              </a:defRPr>
+            </a:pPr>
+            <a:r>
+              <a:t>Task Intent Parsing</a:t>
             </a:r>
           </a:p>
           <a:p>
             <a:pPr>
-              <a:spcAft>
-                <a:spcPts val="600"/>
-              </a:spcAft>
               <a:defRPr sz="1200">
                 <a:solidFill>
-                  <a:srgbClr val="F8FAFC"/>
-                </a:solidFill>
-              </a:defRPr>
-            </a:pPr>
-            <a:r>
-              <a:t>• search_domain_blueprints: Retrieves domain blueprints and milestone phases.</a:t>
-            </a:r>
-          </a:p>
-          <a:p>
-            <a:pPr>
-              <a:spcAft>
-                <a:spcPts val="600"/>
-              </a:spcAft>
-              <a:defRPr sz="1200">
-                <a:solidFill>
-                  <a:srgbClr val="F8FAFC"/>
-                </a:solidFill>
-              </a:defRPr>
-            </a:pPr>
-            <a:r>
-              <a:t>• analyze_goal_feasibility: Tests timeline feasibility and resource limits.</a:t>
-            </a:r>
-          </a:p>
-          <a:p>
-            <a:pPr>
-              <a:spcAft>
-                <a:spcPts val="600"/>
-              </a:spcAft>
-              <a:defRPr sz="1200">
-                <a:solidFill>
-                  <a:srgbClr val="F8FAFC"/>
-                </a:solidFill>
-              </a:defRPr>
-            </a:pPr>
-            <a:r>
-              <a:t>• decompose_into_subtasks: Generates phase-aligned, numbered sub-tasks with deliverables.</a:t>
-            </a:r>
-          </a:p>
-          <a:p>
-            <a:pPr>
-              <a:spcAft>
-                <a:spcPts val="600"/>
-              </a:spcAft>
-              <a:defRPr sz="1200">
-                <a:solidFill>
-                  <a:srgbClr val="F8FAFC"/>
-                </a:solidFill>
-              </a:defRPr>
-            </a:pPr>
-            <a:r>
-              <a:t>• calculate_schedule_and_critical_path: Derives sequential critical path and milestone checkpoints.</a:t>
-            </a:r>
-          </a:p>
-          <a:p>
-            <a:pPr>
-              <a:spcAft>
-                <a:spcPts val="600"/>
-              </a:spcAft>
-              <a:defRPr sz="1200">
-                <a:solidFill>
-                  <a:srgbClr val="F8FAFC"/>
-                </a:solidFill>
-              </a:defRPr>
-            </a:pPr>
-            <a:r>
-              <a:t>• assess_risks_and_mitigations: Identifies failure modes and injects contingency safeguards.</a:t>
-            </a:r>
-          </a:p>
-          <a:p>
-            <a:pPr>
-              <a:spcAft>
-                <a:spcPts val="600"/>
-              </a:spcAft>
-              <a:defRPr sz="1200">
-                <a:solidFill>
-                  <a:srgbClr val="F8FAFC"/>
-                </a:solidFill>
-              </a:defRPr>
-            </a:pPr>
-            <a:r>
-              <a:t>• export_structured_plan: Persists compiled master plan into permanent JSON records.</a:t>
+                  <a:srgbClr val="64748B"/>
+                </a:solidFill>
+              </a:defRPr>
+            </a:pPr>
+            <a:r>
+              <a:t>Extracts primary objective, numerical timeline, budget ceiling, and complexity tier for ANY goal.</a:t>
             </a:r>
           </a:p>
         </p:txBody>
@@ -4341,18 +3854,18 @@
         </p:nvSpPr>
         <p:spPr>
           <a:xfrm>
-            <a:off x="6217920" y="1645920"/>
-            <a:ext cx="5212080" cy="4389120"/>
+            <a:off x="3429000" y="1645920"/>
+            <a:ext cx="2560320" cy="4389120"/>
           </a:xfrm>
           <a:prstGeom prst="roundRect">
             <a:avLst/>
           </a:prstGeom>
           <a:solidFill>
-            <a:srgbClr val="1E293B"/>
+            <a:srgbClr val="FFFFFF"/>
           </a:solidFill>
           <a:ln>
             <a:solidFill>
-              <a:srgbClr val="4ADE80"/>
+              <a:srgbClr val="E2E8F0"/>
             </a:solidFill>
           </a:ln>
         </p:spPr>
@@ -4376,91 +3889,211 @@
           <a:p>
             <a:pPr algn="ctr">
               <a:spcAft>
+                <a:spcPts val="600"/>
+              </a:spcAft>
+              <a:defRPr sz="1600" b="1">
+                <a:solidFill>
+                  <a:srgbClr val="DC2626"/>
+                </a:solidFill>
+              </a:defRPr>
+            </a:pPr>
+            <a:r>
+              <a:t>2. ACT</a:t>
+            </a:r>
+          </a:p>
+          <a:p>
+            <a:pPr>
+              <a:spcAft>
                 <a:spcPts val="1000"/>
               </a:spcAft>
-              <a:defRPr sz="1800" b="1">
-                <a:solidFill>
-                  <a:srgbClr val="4ADE80"/>
-                </a:solidFill>
-              </a:defRPr>
-            </a:pPr>
-            <a:r>
-              <a:t>🌸 Benchmark: 'Plan a 3-Day Trip to Tokyo'</a:t>
+              <a:defRPr sz="1300" b="1">
+                <a:solidFill>
+                  <a:srgbClr val="0F172A"/>
+                </a:solidFill>
+              </a:defRPr>
+            </a:pPr>
+            <a:r>
+              <a:t>Universal Tool Invocations</a:t>
             </a:r>
           </a:p>
           <a:p>
             <a:pPr>
+              <a:defRPr sz="1200">
+                <a:solidFill>
+                  <a:srgbClr val="64748B"/>
+                </a:solidFill>
+              </a:defRPr>
+            </a:pPr>
+            <a:r>
+              <a:t>Calls specialized tools: intent analyzer, feasibility auditor, subtask decomposer, critical path scheduler.</a:t>
+            </a:r>
+          </a:p>
+        </p:txBody>
+      </p:sp>
+      <p:sp>
+        <p:nvSpPr>
+          <p:cNvPr id="7" name="Rounded Rectangle 6"/>
+          <p:cNvSpPr/>
+          <p:nvPr/>
+        </p:nvSpPr>
+        <p:spPr>
+          <a:xfrm>
+            <a:off x="6126480" y="1645920"/>
+            <a:ext cx="2560320" cy="4389120"/>
+          </a:xfrm>
+          <a:prstGeom prst="roundRect">
+            <a:avLst/>
+          </a:prstGeom>
+          <a:solidFill>
+            <a:srgbClr val="FFFFFF"/>
+          </a:solidFill>
+          <a:ln>
+            <a:solidFill>
+              <a:srgbClr val="E2E8F0"/>
+            </a:solidFill>
+          </a:ln>
+        </p:spPr>
+        <p:style>
+          <a:lnRef idx="1">
+            <a:schemeClr val="accent1"/>
+          </a:lnRef>
+          <a:fillRef idx="3">
+            <a:schemeClr val="accent1"/>
+          </a:fillRef>
+          <a:effectRef idx="2">
+            <a:schemeClr val="accent1"/>
+          </a:effectRef>
+          <a:fontRef idx="minor">
+            <a:schemeClr val="lt1"/>
+          </a:fontRef>
+        </p:style>
+        <p:txBody>
+          <a:bodyPr rtlCol="0" anchor="ctr" wrap="square"/>
+          <a:lstStyle/>
+          <a:p>
+            <a:pPr algn="ctr">
               <a:spcAft>
                 <a:spcPts val="600"/>
               </a:spcAft>
+              <a:defRPr sz="1600" b="1">
+                <a:solidFill>
+                  <a:srgbClr val="DC2626"/>
+                </a:solidFill>
+              </a:defRPr>
+            </a:pPr>
+            <a:r>
+              <a:t>3. OBSERVE</a:t>
+            </a:r>
+          </a:p>
+          <a:p>
+            <a:pPr>
+              <a:spcAft>
+                <a:spcPts val="1000"/>
+              </a:spcAft>
+              <a:defRPr sz="1300" b="1">
+                <a:solidFill>
+                  <a:srgbClr val="0F172A"/>
+                </a:solidFill>
+              </a:defRPr>
+            </a:pPr>
+            <a:r>
+              <a:t>Telemetry Scratchpad</a:t>
+            </a:r>
+          </a:p>
+          <a:p>
+            <a:pPr>
               <a:defRPr sz="1200">
                 <a:solidFill>
-                  <a:srgbClr val="F8FAFC"/>
-                </a:solidFill>
-              </a:defRPr>
-            </a:pPr>
-            <a:r>
-              <a:t>• Input Goal: 'Plan a 3-day cultural &amp; culinary trip to Tokyo for 2 people on a $1,200 budget.'</a:t>
-            </a:r>
-          </a:p>
-          <a:p>
-            <a:pPr>
+                  <a:srgbClr val="64748B"/>
+                </a:solidFill>
+              </a:defRPr>
+            </a:pPr>
+            <a:r>
+              <a:t>Accumulates structured observations and constraint checks into Pydantic AgentState memory.</a:t>
+            </a:r>
+          </a:p>
+        </p:txBody>
+      </p:sp>
+      <p:sp>
+        <p:nvSpPr>
+          <p:cNvPr id="8" name="Rounded Rectangle 7"/>
+          <p:cNvSpPr/>
+          <p:nvPr/>
+        </p:nvSpPr>
+        <p:spPr>
+          <a:xfrm>
+            <a:off x="8823960" y="1645920"/>
+            <a:ext cx="2560320" cy="4389120"/>
+          </a:xfrm>
+          <a:prstGeom prst="roundRect">
+            <a:avLst/>
+          </a:prstGeom>
+          <a:solidFill>
+            <a:srgbClr val="FFFFFF"/>
+          </a:solidFill>
+          <a:ln>
+            <a:solidFill>
+              <a:srgbClr val="DC2626"/>
+            </a:solidFill>
+          </a:ln>
+        </p:spPr>
+        <p:style>
+          <a:lnRef idx="1">
+            <a:schemeClr val="accent1"/>
+          </a:lnRef>
+          <a:fillRef idx="3">
+            <a:schemeClr val="accent1"/>
+          </a:fillRef>
+          <a:effectRef idx="2">
+            <a:schemeClr val="accent1"/>
+          </a:effectRef>
+          <a:fontRef idx="minor">
+            <a:schemeClr val="lt1"/>
+          </a:fontRef>
+        </p:style>
+        <p:txBody>
+          <a:bodyPr rtlCol="0" anchor="ctr" wrap="square"/>
+          <a:lstStyle/>
+          <a:p>
+            <a:pPr algn="ctr">
               <a:spcAft>
                 <a:spcPts val="600"/>
               </a:spcAft>
-              <a:defRPr sz="1200">
-                <a:solidFill>
-                  <a:srgbClr val="F8FAFC"/>
-                </a:solidFill>
-              </a:defRPr>
-            </a:pPr>
-            <a:r>
-              <a:t>• Phase 1 Logistics: Lodging reservation, flight transfers, local eSIM data, and IC transit card pre-orders.</a:t>
+              <a:defRPr sz="1600" b="1">
+                <a:solidFill>
+                  <a:srgbClr val="DC2626"/>
+                </a:solidFill>
+              </a:defRPr>
+            </a:pPr>
+            <a:r>
+              <a:t>4. RESPOND</a:t>
             </a:r>
           </a:p>
           <a:p>
             <a:pPr>
               <a:spcAft>
-                <a:spcPts val="600"/>
+                <a:spcPts val="1000"/>
               </a:spcAft>
+              <a:defRPr sz="1300" b="1">
+                <a:solidFill>
+                  <a:srgbClr val="0F172A"/>
+                </a:solidFill>
+              </a:defRPr>
+            </a:pPr>
+            <a:r>
+              <a:t>Master Plan Synthesis</a:t>
+            </a:r>
+          </a:p>
+          <a:p>
+            <a:pPr>
               <a:defRPr sz="1200">
                 <a:solidFill>
-                  <a:srgbClr val="F8FAFC"/>
-                </a:solidFill>
-              </a:defRPr>
-            </a:pPr>
-            <a:r>
-              <a:t>• Phase 2 Itinerary: Day 1 arrival &amp; orientation walk; Day 2 Asakusa &amp; culinary food tour; Day 3 Meiji Shrine &amp; market shopping.</a:t>
-            </a:r>
-          </a:p>
-          <a:p>
-            <a:pPr>
-              <a:spcAft>
-                <a:spcPts val="600"/>
-              </a:spcAft>
-              <a:defRPr sz="1200">
-                <a:solidFill>
-                  <a:srgbClr val="F8FAFC"/>
-                </a:solidFill>
-              </a:defRPr>
-            </a:pPr>
-            <a:r>
-              <a:t>• Budget Optimization: Allocates 35% lodging ($420), 25% transit ($300), 20% dining ($240), 12% activities ($144), 8% buffer ($96).</a:t>
-            </a:r>
-          </a:p>
-          <a:p>
-            <a:pPr>
-              <a:spcAft>
-                <a:spcPts val="600"/>
-              </a:spcAft>
-              <a:defRPr sz="1200">
-                <a:solidFill>
-                  <a:srgbClr val="F8FAFC"/>
-                </a:solidFill>
-              </a:defRPr>
-            </a:pPr>
-            <a:r>
-              <a:t>• Risk Mitigation: Pre-downloads offline transit maps and schedules open-date vouchers for rainy weather.</a:t>
+                  <a:srgbClr val="64748B"/>
+                </a:solidFill>
+              </a:defRPr>
+            </a:pPr>
+            <a:r>
+              <a:t>Compiles phase matrix, milestone timeline, risk safeguards, and persists plan with unique Plan ID.</a:t>
             </a:r>
           </a:p>
         </p:txBody>
@@ -4473,7 +4106,7 @@
 </p:sld>
 </file>
 
-<file path=ppt/slides/slide5.xml><?xml version="1.0" encoding="utf-8"?>
+<file path=ppt/slides/slide4.xml><?xml version="1.0" encoding="utf-8"?>
 <p:sld xmlns:a="http://schemas.openxmlformats.org/drawingml/2006/main" xmlns:p="http://schemas.openxmlformats.org/presentationml/2006/main" xmlns:r="http://schemas.openxmlformats.org/officeDocument/2006/relationships">
   <p:cSld>
     <p:spTree>
@@ -4498,7 +4131,7 @@
             <a:avLst/>
           </a:prstGeom>
           <a:solidFill>
-            <a:srgbClr val="0F172A"/>
+            <a:srgbClr val="FAFAFC"/>
           </a:solidFill>
           <a:ln>
             <a:noFill/>
@@ -4551,12 +4184,12 @@
             <a:pPr>
               <a:defRPr sz="1100" b="1">
                 <a:solidFill>
-                  <a:srgbClr val="38BDF8"/>
-                </a:solidFill>
-              </a:defRPr>
-            </a:pPr>
-            <a:r>
-              <a:t>04 / BENCHMARKS &amp; COMPLIANCE</a:t>
+                  <a:srgbClr val="DC2626"/>
+                </a:solidFill>
+              </a:defRPr>
+            </a:pPr>
+            <a:r>
+              <a:t>03 / TOOL SUITE &amp; BENCHMARKS</a:t>
             </a:r>
           </a:p>
         </p:txBody>
@@ -4586,12 +4219,12 @@
             <a:pPr>
               <a:defRPr sz="2600" b="1">
                 <a:solidFill>
-                  <a:srgbClr val="F8FAFC"/>
-                </a:solidFill>
-              </a:defRPr>
-            </a:pPr>
-            <a:r>
-              <a:t>Test Coverage, Technology Stack &amp; Contest Compliance</a:t>
+                  <a:srgbClr val="0F172A"/>
+                </a:solidFill>
+              </a:defRPr>
+            </a:pPr>
+            <a:r>
+              <a:t>Universal Tool Suite &amp; Multi-Domain Planning Capabilities</a:t>
             </a:r>
           </a:p>
         </p:txBody>
@@ -4605,17 +4238,17 @@
         <p:spPr>
           <a:xfrm>
             <a:off x="731520" y="1645920"/>
-            <a:ext cx="10698480" cy="4389120"/>
+            <a:ext cx="5120640" cy="4389120"/>
           </a:xfrm>
           <a:prstGeom prst="roundRect">
             <a:avLst/>
           </a:prstGeom>
           <a:solidFill>
-            <a:srgbClr val="1E293B"/>
+            <a:srgbClr val="FFFFFF"/>
           </a:solidFill>
           <a:ln>
             <a:solidFill>
-              <a:srgbClr val="4ADE80"/>
+              <a:srgbClr val="E2E8F0"/>
             </a:solidFill>
           </a:ln>
         </p:spPr>
@@ -4639,11 +4272,421 @@
           <a:p>
             <a:pPr algn="ctr">
               <a:spcAft>
+                <a:spcPts val="1000"/>
+              </a:spcAft>
+              <a:defRPr sz="1800" b="1">
+                <a:solidFill>
+                  <a:srgbClr val="DC2626"/>
+                </a:solidFill>
+              </a:defRPr>
+            </a:pPr>
+            <a:r>
+              <a:t>🛠️ Autonomous Planning Tools</a:t>
+            </a:r>
+          </a:p>
+          <a:p>
+            <a:pPr>
+              <a:spcAft>
+                <a:spcPts val="600"/>
+              </a:spcAft>
+              <a:defRPr sz="1200">
+                <a:solidFill>
+                  <a:srgbClr val="0F172A"/>
+                </a:solidFill>
+              </a:defRPr>
+            </a:pPr>
+            <a:r>
+              <a:t>• analyze_task_intent: Extracts goal intent, domain category, timeline constraints &amp; complexity.</a:t>
+            </a:r>
+          </a:p>
+          <a:p>
+            <a:pPr>
+              <a:spcAft>
+                <a:spcPts val="600"/>
+              </a:spcAft>
+              <a:defRPr sz="1200">
+                <a:solidFill>
+                  <a:srgbClr val="0F172A"/>
+                </a:solidFill>
+              </a:defRPr>
+            </a:pPr>
+            <a:r>
+              <a:t>• audit_feasibility_and_effort: Computes workload hours, feasibility scores (0-100) &amp; bottlenecks.</a:t>
+            </a:r>
+          </a:p>
+          <a:p>
+            <a:pPr>
+              <a:spcAft>
+                <a:spcPts val="600"/>
+              </a:spcAft>
+              <a:defRPr sz="1200">
+                <a:solidFill>
+                  <a:srgbClr val="0F172A"/>
+                </a:solidFill>
+              </a:defRPr>
+            </a:pPr>
+            <a:r>
+              <a:t>• decompose_any_task: Universally breaks down any task into 4 phased, chronological deliverables.</a:t>
+            </a:r>
+          </a:p>
+          <a:p>
+            <a:pPr>
+              <a:spcAft>
+                <a:spcPts val="600"/>
+              </a:spcAft>
+              <a:defRPr sz="1200">
+                <a:solidFill>
+                  <a:srgbClr val="0F172A"/>
+                </a:solidFill>
+              </a:defRPr>
+            </a:pPr>
+            <a:r>
+              <a:t>• derive_critical_path_and_milestones: Calculates sequential critical paths &amp; 3 progress gates.</a:t>
+            </a:r>
+          </a:p>
+          <a:p>
+            <a:pPr>
+              <a:spcAft>
+                <a:spcPts val="600"/>
+              </a:spcAft>
+              <a:defRPr sz="1200">
+                <a:solidFill>
+                  <a:srgbClr val="0F172A"/>
+                </a:solidFill>
+              </a:defRPr>
+            </a:pPr>
+            <a:r>
+              <a:t>• audit_failure_modes_and_safeguards: Identifies operational risks &amp; automated mitigations.</a:t>
+            </a:r>
+          </a:p>
+          <a:p>
+            <a:pPr>
+              <a:spcAft>
+                <a:spcPts val="600"/>
+              </a:spcAft>
+              <a:defRPr sz="1200">
+                <a:solidFill>
+                  <a:srgbClr val="0F172A"/>
+                </a:solidFill>
+              </a:defRPr>
+            </a:pPr>
+            <a:r>
+              <a:t>• persist_master_plan: Archives compiled master plans into permanent JSON storage.</a:t>
+            </a:r>
+          </a:p>
+        </p:txBody>
+      </p:sp>
+      <p:sp>
+        <p:nvSpPr>
+          <p:cNvPr id="6" name="Rounded Rectangle 5"/>
+          <p:cNvSpPr/>
+          <p:nvPr/>
+        </p:nvSpPr>
+        <p:spPr>
+          <a:xfrm>
+            <a:off x="6217920" y="1645920"/>
+            <a:ext cx="5212080" cy="4389120"/>
+          </a:xfrm>
+          <a:prstGeom prst="roundRect">
+            <a:avLst/>
+          </a:prstGeom>
+          <a:solidFill>
+            <a:srgbClr val="FFFFFF"/>
+          </a:solidFill>
+          <a:ln>
+            <a:solidFill>
+              <a:srgbClr val="DC2626"/>
+            </a:solidFill>
+          </a:ln>
+        </p:spPr>
+        <p:style>
+          <a:lnRef idx="1">
+            <a:schemeClr val="accent1"/>
+          </a:lnRef>
+          <a:fillRef idx="3">
+            <a:schemeClr val="accent1"/>
+          </a:fillRef>
+          <a:effectRef idx="2">
+            <a:schemeClr val="accent1"/>
+          </a:effectRef>
+          <a:fontRef idx="minor">
+            <a:schemeClr val="lt1"/>
+          </a:fontRef>
+        </p:style>
+        <p:txBody>
+          <a:bodyPr rtlCol="0" anchor="ctr" wrap="square"/>
+          <a:lstStyle/>
+          <a:p>
+            <a:pPr algn="ctr">
+              <a:spcAft>
+                <a:spcPts val="1000"/>
+              </a:spcAft>
+              <a:defRPr sz="1800" b="1">
+                <a:solidFill>
+                  <a:srgbClr val="991B1B"/>
+                </a:solidFill>
+              </a:defRPr>
+            </a:pPr>
+            <a:r>
+              <a:t>🌐 Tested Across Diverse Domains</a:t>
+            </a:r>
+          </a:p>
+          <a:p>
+            <a:pPr>
+              <a:spcAft>
+                <a:spcPts val="600"/>
+              </a:spcAft>
+              <a:defRPr sz="1200">
+                <a:solidFill>
+                  <a:srgbClr val="0F172A"/>
+                </a:solidFill>
+              </a:defRPr>
+            </a:pPr>
+            <a:r>
+              <a:t>• Travel &amp; Trips: 'Plan a 3-day trip to Tokyo for 2 people on a $1,200 budget.' (Phased daily itinerary, transit &amp; lodging).</a:t>
+            </a:r>
+          </a:p>
+          <a:p>
+            <a:pPr>
+              <a:spcAft>
+                <a:spcPts val="600"/>
+              </a:spcAft>
+              <a:defRPr sz="1200">
+                <a:solidFill>
+                  <a:srgbClr val="0F172A"/>
+                </a:solidFill>
+              </a:defRPr>
+            </a:pPr>
+            <a:r>
+              <a:t>• Software Engineering: 'Build and launch a SaaS AI MVP in 4 weeks with authentication and billing.' (PRD, backend, frontend, testing).</a:t>
+            </a:r>
+          </a:p>
+          <a:p>
+            <a:pPr>
+              <a:spcAft>
+                <a:spcPts val="600"/>
+              </a:spcAft>
+              <a:defRPr sz="1200">
+                <a:solidFill>
+                  <a:srgbClr val="0F172A"/>
+                </a:solidFill>
+              </a:defRPr>
+            </a:pPr>
+            <a:r>
+              <a:t>• Exam Prep &amp; Certifications: 'Prepare for AWS Solutions Architect in 30 days.' (Study milestones, practice labs, revision).</a:t>
+            </a:r>
+          </a:p>
+          <a:p>
+            <a:pPr>
+              <a:spcAft>
+                <a:spcPts val="600"/>
+              </a:spcAft>
+              <a:defRPr sz="1200">
+                <a:solidFill>
+                  <a:srgbClr val="0F172A"/>
+                </a:solidFill>
+              </a:defRPr>
+            </a:pPr>
+            <a:r>
+              <a:t>• Events &amp; Hackathons: 'Organize a 2-day technical hackathon for 100 participants in 3 weeks.' (Venue, prizes, mentorship).</a:t>
+            </a:r>
+          </a:p>
+          <a:p>
+            <a:pPr>
+              <a:spcAft>
+                <a:spcPts val="600"/>
+              </a:spcAft>
+              <a:defRPr sz="1200">
+                <a:solidFill>
+                  <a:srgbClr val="0F172A"/>
+                </a:solidFill>
+              </a:defRPr>
+            </a:pPr>
+            <a:r>
+              <a:t>• Domestic &amp; Lifestyle: 'Renovate apartment with $5,000 budget' or 'Train for a half marathon in 10 weeks.'</a:t>
+            </a:r>
+          </a:p>
+        </p:txBody>
+      </p:sp>
+    </p:spTree>
+  </p:cSld>
+  <p:clrMapOvr>
+    <a:masterClrMapping/>
+  </p:clrMapOvr>
+</p:sld>
+</file>
+
+<file path=ppt/slides/slide5.xml><?xml version="1.0" encoding="utf-8"?>
+<p:sld xmlns:a="http://schemas.openxmlformats.org/drawingml/2006/main" xmlns:p="http://schemas.openxmlformats.org/presentationml/2006/main" xmlns:r="http://schemas.openxmlformats.org/officeDocument/2006/relationships">
+  <p:cSld>
+    <p:spTree>
+      <p:nvGrpSpPr>
+        <p:cNvPr id="1" name=""/>
+        <p:cNvGrpSpPr/>
+        <p:nvPr/>
+      </p:nvGrpSpPr>
+      <p:grpSpPr/>
+      <p:sp>
+        <p:nvSpPr>
+          <p:cNvPr id="2" name="Rectangle 1"/>
+          <p:cNvSpPr/>
+          <p:nvPr/>
+        </p:nvSpPr>
+        <p:spPr>
+          <a:xfrm>
+            <a:off x="0" y="0"/>
+            <a:ext cx="12191695" cy="6858000"/>
+          </a:xfrm>
+          <a:prstGeom prst="rect">
+            <a:avLst/>
+          </a:prstGeom>
+          <a:solidFill>
+            <a:srgbClr val="FAFAFC"/>
+          </a:solidFill>
+          <a:ln>
+            <a:noFill/>
+          </a:ln>
+        </p:spPr>
+        <p:style>
+          <a:lnRef idx="1">
+            <a:schemeClr val="accent1"/>
+          </a:lnRef>
+          <a:fillRef idx="3">
+            <a:schemeClr val="accent1"/>
+          </a:fillRef>
+          <a:effectRef idx="2">
+            <a:schemeClr val="accent1"/>
+          </a:effectRef>
+          <a:fontRef idx="minor">
+            <a:schemeClr val="lt1"/>
+          </a:fontRef>
+        </p:style>
+        <p:txBody>
+          <a:bodyPr rtlCol="0" anchor="ctr"/>
+          <a:lstStyle/>
+          <a:p>
+            <a:pPr algn="ctr"/>
+          </a:p>
+        </p:txBody>
+      </p:sp>
+      <p:sp>
+        <p:nvSpPr>
+          <p:cNvPr id="3" name="TextBox 2"/>
+          <p:cNvSpPr txBox="1"/>
+          <p:nvPr/>
+        </p:nvSpPr>
+        <p:spPr>
+          <a:xfrm>
+            <a:off x="731520" y="457200"/>
+            <a:ext cx="10698480" cy="365760"/>
+          </a:xfrm>
+          <a:prstGeom prst="rect">
+            <a:avLst/>
+          </a:prstGeom>
+          <a:noFill/>
+        </p:spPr>
+        <p:txBody>
+          <a:bodyPr wrap="square">
+            <a:spAutoFit/>
+          </a:bodyPr>
+          <a:lstStyle/>
+          <a:p>
+            <a:pPr>
+              <a:defRPr sz="1100" b="1">
+                <a:solidFill>
+                  <a:srgbClr val="DC2626"/>
+                </a:solidFill>
+              </a:defRPr>
+            </a:pPr>
+            <a:r>
+              <a:t>04 / BENCHMARKS &amp; COMPLIANCE</a:t>
+            </a:r>
+          </a:p>
+        </p:txBody>
+      </p:sp>
+      <p:sp>
+        <p:nvSpPr>
+          <p:cNvPr id="4" name="TextBox 3"/>
+          <p:cNvSpPr txBox="1"/>
+          <p:nvPr/>
+        </p:nvSpPr>
+        <p:spPr>
+          <a:xfrm>
+            <a:off x="731520" y="731520"/>
+            <a:ext cx="10698480" cy="731520"/>
+          </a:xfrm>
+          <a:prstGeom prst="rect">
+            <a:avLst/>
+          </a:prstGeom>
+          <a:noFill/>
+        </p:spPr>
+        <p:txBody>
+          <a:bodyPr wrap="square">
+            <a:spAutoFit/>
+          </a:bodyPr>
+          <a:lstStyle/>
+          <a:p>
+            <a:pPr>
+              <a:defRPr sz="2600" b="1">
+                <a:solidFill>
+                  <a:srgbClr val="0F172A"/>
+                </a:solidFill>
+              </a:defRPr>
+            </a:pPr>
+            <a:r>
+              <a:t>Test Coverage, Technology Stack &amp; Contest Compliance</a:t>
+            </a:r>
+          </a:p>
+        </p:txBody>
+      </p:sp>
+      <p:sp>
+        <p:nvSpPr>
+          <p:cNvPr id="5" name="Rounded Rectangle 4"/>
+          <p:cNvSpPr/>
+          <p:nvPr/>
+        </p:nvSpPr>
+        <p:spPr>
+          <a:xfrm>
+            <a:off x="731520" y="1645920"/>
+            <a:ext cx="10698480" cy="4389120"/>
+          </a:xfrm>
+          <a:prstGeom prst="roundRect">
+            <a:avLst/>
+          </a:prstGeom>
+          <a:solidFill>
+            <a:srgbClr val="FFFFFF"/>
+          </a:solidFill>
+          <a:ln>
+            <a:solidFill>
+              <a:srgbClr val="E2E8F0"/>
+            </a:solidFill>
+          </a:ln>
+        </p:spPr>
+        <p:style>
+          <a:lnRef idx="1">
+            <a:schemeClr val="accent1"/>
+          </a:lnRef>
+          <a:fillRef idx="3">
+            <a:schemeClr val="accent1"/>
+          </a:fillRef>
+          <a:effectRef idx="2">
+            <a:schemeClr val="accent1"/>
+          </a:effectRef>
+          <a:fontRef idx="minor">
+            <a:schemeClr val="lt1"/>
+          </a:fontRef>
+        </p:style>
+        <p:txBody>
+          <a:bodyPr rtlCol="0" anchor="ctr" wrap="square"/>
+          <a:lstStyle/>
+          <a:p>
+            <a:pPr algn="ctr">
+              <a:spcAft>
                 <a:spcPts val="1200"/>
               </a:spcAft>
               <a:defRPr sz="1800" b="1">
                 <a:solidFill>
-                  <a:srgbClr val="4ADE80"/>
+                  <a:srgbClr val="DC2626"/>
                 </a:solidFill>
               </a:defRPr>
             </a:pPr>
@@ -4658,12 +4701,12 @@
               </a:spcAft>
               <a:defRPr sz="1300">
                 <a:solidFill>
-                  <a:srgbClr val="F8FAFC"/>
-                </a:solidFill>
-              </a:defRPr>
-            </a:pPr>
-            <a:r>
-              <a:t>✔ 100% Automated Test Suite: 6 automated unit tests validating blueprint search, feasibility scoring, 3-day subtask decomposition, critical path derivation, risk assessment, and end-to-end plan generation.</a:t>
+                  <a:srgbClr val="0F172A"/>
+                </a:solidFill>
+              </a:defRPr>
+            </a:pPr>
+            <a:r>
+              <a:t>✔ 100% Automated Test Suite: 6 automated unit tests validating intent extraction, feasibility scoring, arbitrary task decomposition, critical path derivation, risk safeguards, and end-to-end plan generation.</a:t>
             </a:r>
           </a:p>
           <a:p>
@@ -4673,7 +4716,7 @@
               </a:spcAft>
               <a:defRPr sz="1300">
                 <a:solidFill>
-                  <a:srgbClr val="F8FAFC"/>
+                  <a:srgbClr val="0F172A"/>
                 </a:solidFill>
               </a:defRPr>
             </a:pPr>
@@ -4688,7 +4731,7 @@
               </a:spcAft>
               <a:defRPr sz="1300">
                 <a:solidFill>
-                  <a:srgbClr val="F8FAFC"/>
+                  <a:srgbClr val="0F172A"/>
                 </a:solidFill>
               </a:defRPr>
             </a:pPr>
@@ -4703,12 +4746,12 @@
               </a:spcAft>
               <a:defRPr sz="1300">
                 <a:solidFill>
-                  <a:srgbClr val="F8FAFC"/>
-                </a:solidFill>
-              </a:defRPr>
-            </a:pPr>
-            <a:r>
-              <a:t>✔ Dual Operational Interfaces: Interactive Streamlit Web UI with live reasoning inspector and 1-click test scenarios + rich terminal CLI.</a:t>
+                  <a:srgbClr val="0F172A"/>
+                </a:solidFill>
+              </a:defRPr>
+            </a:pPr>
+            <a:r>
+              <a:t>✔ Ultra-Smooth Red &amp; White Gemini UI: Minimalist, clean user interface styled with crimson red accents and floating suggestion chips.</a:t>
             </a:r>
           </a:p>
           <a:p>
@@ -4718,7 +4761,7 @@
               </a:spcAft>
               <a:defRPr sz="1300">
                 <a:solidFill>
-                  <a:srgbClr val="F8FAFC"/>
+                  <a:srgbClr val="0F172A"/>
                 </a:solidFill>
               </a:defRPr>
             </a:pPr>

</xml_diff>

<commit_message>
feat: complete Chatbot Techvruk - Autonomous AI Task Planner with Gemini 3.5 Flash Lite and rich UI
</commit_message>
<xml_diff>
--- a/Techvruk_Agentic_System_Presentation.pptx
+++ b/Techvruk_Agentic_System_Presentation.pptx
@@ -3085,6 +3085,14 @@
 <file path=ppt/slides/slide1.xml><?xml version="1.0" encoding="utf-8"?>
 <p:sld xmlns:a="http://schemas.openxmlformats.org/drawingml/2006/main" xmlns:p="http://schemas.openxmlformats.org/presentationml/2006/main" xmlns:r="http://schemas.openxmlformats.org/officeDocument/2006/relationships">
   <p:cSld>
+    <p:bg>
+      <p:bgPr>
+        <a:solidFill>
+          <a:srgbClr val="131314"/>
+        </a:solidFill>
+        <a:effectLst/>
+      </p:bgPr>
+    </p:bg>
     <p:spTree>
       <p:nvGrpSpPr>
         <p:cNvPr id="1" name=""/>
@@ -3094,100 +3102,14 @@
       <p:grpSpPr/>
       <p:sp>
         <p:nvSpPr>
-          <p:cNvPr id="2" name="Rectangle 1"/>
-          <p:cNvSpPr/>
+          <p:cNvPr id="2" name="TextBox 1"/>
+          <p:cNvSpPr txBox="1"/>
           <p:nvPr/>
         </p:nvSpPr>
         <p:spPr>
           <a:xfrm>
-            <a:off x="0" y="0"/>
-            <a:ext cx="12191695" cy="6858000"/>
-          </a:xfrm>
-          <a:prstGeom prst="rect">
-            <a:avLst/>
-          </a:prstGeom>
-          <a:solidFill>
-            <a:srgbClr val="FAFAFC"/>
-          </a:solidFill>
-          <a:ln>
-            <a:noFill/>
-          </a:ln>
-        </p:spPr>
-        <p:style>
-          <a:lnRef idx="1">
-            <a:schemeClr val="accent1"/>
-          </a:lnRef>
-          <a:fillRef idx="3">
-            <a:schemeClr val="accent1"/>
-          </a:fillRef>
-          <a:effectRef idx="2">
-            <a:schemeClr val="accent1"/>
-          </a:effectRef>
-          <a:fontRef idx="minor">
-            <a:schemeClr val="lt1"/>
-          </a:fontRef>
-        </p:style>
-        <p:txBody>
-          <a:bodyPr rtlCol="0" anchor="ctr"/>
-          <a:lstStyle/>
-          <a:p>
-            <a:pPr algn="ctr"/>
-          </a:p>
-        </p:txBody>
-      </p:sp>
-      <p:sp>
-        <p:nvSpPr>
-          <p:cNvPr id="3" name="Rectangle 2"/>
-          <p:cNvSpPr/>
-          <p:nvPr/>
-        </p:nvSpPr>
-        <p:spPr>
-          <a:xfrm>
-            <a:off x="1097280" y="1371600"/>
-            <a:ext cx="731520" cy="73152"/>
-          </a:xfrm>
-          <a:prstGeom prst="rect">
-            <a:avLst/>
-          </a:prstGeom>
-          <a:solidFill>
-            <a:srgbClr val="DC2626"/>
-          </a:solidFill>
-          <a:ln>
-            <a:noFill/>
-          </a:ln>
-        </p:spPr>
-        <p:style>
-          <a:lnRef idx="1">
-            <a:schemeClr val="accent1"/>
-          </a:lnRef>
-          <a:fillRef idx="3">
-            <a:schemeClr val="accent1"/>
-          </a:fillRef>
-          <a:effectRef idx="2">
-            <a:schemeClr val="accent1"/>
-          </a:effectRef>
-          <a:fontRef idx="minor">
-            <a:schemeClr val="lt1"/>
-          </a:fontRef>
-        </p:style>
-        <p:txBody>
-          <a:bodyPr rtlCol="0" anchor="ctr"/>
-          <a:lstStyle/>
-          <a:p>
-            <a:pPr algn="ctr"/>
-          </a:p>
-        </p:txBody>
-      </p:sp>
-      <p:sp>
-        <p:nvSpPr>
-          <p:cNvPr id="4" name="TextBox 3"/>
-          <p:cNvSpPr txBox="1"/>
-          <p:nvPr/>
-        </p:nvSpPr>
-        <p:spPr>
-          <a:xfrm>
-            <a:off x="1097280" y="1645920"/>
-            <a:ext cx="10058400" cy="4114800"/>
+            <a:off x="731520" y="731520"/>
+            <a:ext cx="10698480" cy="1097280"/>
           </a:xfrm>
           <a:prstGeom prst="rect">
             <a:avLst/>
@@ -3201,67 +3123,110 @@
           <a:lstStyle/>
           <a:p>
             <a:pPr>
-              <a:spcAft>
-                <a:spcPts val="1400"/>
-              </a:spcAft>
-              <a:defRPr sz="1300" b="1">
-                <a:solidFill>
-                  <a:srgbClr val="DC2626"/>
+              <a:defRPr sz="3600" b="1">
+                <a:solidFill>
+                  <a:srgbClr val="9B72CB"/>
                 </a:solidFill>
               </a:defRPr>
             </a:pPr>
             <a:r>
-              <a:t>TECHVRUK AI CONTEST SUBMISSION • UNIVERSAL AGENTIC SYSTEM</a:t>
-            </a:r>
-          </a:p>
+              <a:t>✦ Chatbot Techvruk</a:t>
+            </a:r>
+          </a:p>
+          <a:p>
+            <a:pPr>
+              <a:defRPr sz="1800">
+                <a:solidFill>
+                  <a:srgbClr val="8E918F"/>
+                </a:solidFill>
+              </a:defRPr>
+            </a:pPr>
+            <a:r>
+              <a:t>Autonomous Multi-Currency AI Agent for General Task Orchestration</a:t>
+            </a:r>
+          </a:p>
+        </p:txBody>
+      </p:sp>
+      <p:sp>
+        <p:nvSpPr>
+          <p:cNvPr id="3" name="TextBox 2"/>
+          <p:cNvSpPr txBox="1"/>
+          <p:nvPr/>
+        </p:nvSpPr>
+        <p:spPr>
+          <a:xfrm>
+            <a:off x="731520" y="2011680"/>
+            <a:ext cx="10698480" cy="4114800"/>
+          </a:xfrm>
+          <a:prstGeom prst="rect">
+            <a:avLst/>
+          </a:prstGeom>
+          <a:noFill/>
+        </p:spPr>
+        <p:txBody>
+          <a:bodyPr wrap="square">
+            <a:spAutoFit/>
+          </a:bodyPr>
+          <a:lstStyle/>
+          <a:p/>
           <a:p>
             <a:pPr>
               <a:spcAft>
-                <a:spcPts val="1600"/>
+                <a:spcPts val="1800"/>
               </a:spcAft>
-              <a:defRPr sz="3600" b="1">
-                <a:solidFill>
-                  <a:srgbClr val="0F172A"/>
+              <a:defRPr sz="2000">
+                <a:solidFill>
+                  <a:srgbClr val="F0F4F9"/>
                 </a:solidFill>
               </a:defRPr>
             </a:pPr>
             <a:r>
-              <a:t>Universal Task Planner Agent</a:t>
-            </a:r>
-            <a:br/>
-            <a:r>
-              <a:t>Autonomous Goal Decomposition for ANY Task</a:t>
+              <a:t>• Autonomous ReAct Workflow: Plan -&gt; Act -&gt; Observe -&gt; Adjust -&gt; Respond</a:t>
             </a:r>
           </a:p>
           <a:p>
             <a:pPr>
               <a:spcAft>
-                <a:spcPts val="3200"/>
+                <a:spcPts val="1800"/>
               </a:spcAft>
-              <a:defRPr sz="1600">
-                <a:solidFill>
-                  <a:srgbClr val="64748B"/>
+              <a:defRPr sz="2000">
+                <a:solidFill>
+                  <a:srgbClr val="F0F4F9"/>
                 </a:solidFill>
               </a:defRPr>
             </a:pPr>
             <a:r>
-              <a:t>Accepts any arbitrary goal (e.g. travel, software development, exam prep, event planning)</a:t>
-            </a:r>
-            <a:br/>
-            <a:r>
-              <a:t>and autonomously deconstructs it into phased subtasks, critical path schedules, and risk safeguards.</a:t>
+              <a:t>• General-Purpose: Plans ANY task (Travel, Software MVP, Events, Marketing, Renovation, etc.)</a:t>
             </a:r>
           </a:p>
           <a:p>
             <a:pPr>
-              <a:defRPr sz="1400" b="1">
-                <a:solidFill>
-                  <a:srgbClr val="991B1B"/>
+              <a:spcAft>
+                <a:spcPts val="1800"/>
+              </a:spcAft>
+              <a:defRPr sz="2000">
+                <a:solidFill>
+                  <a:srgbClr val="F0F4F9"/>
                 </a:solidFill>
               </a:defRPr>
             </a:pPr>
             <a:r>
-              <a:t>Candidate: Anandha Raaman S  |  Stack: Python, Pydantic, Gemini API / Offline Engine, Streamlit (Red &amp; White Theme)</a:t>
+              <a:t>• Arbitrary Multi-Currency Budgeting: 35+ Global Currencies with 12% Contingency Reserve</a:t>
+            </a:r>
+          </a:p>
+          <a:p>
+            <a:pPr>
+              <a:spcAft>
+                <a:spcPts val="1800"/>
+              </a:spcAft>
+              <a:defRPr sz="2000">
+                <a:solidFill>
+                  <a:srgbClr val="F0F4F9"/>
+                </a:solidFill>
+              </a:defRPr>
+            </a:pPr>
+            <a:r>
+              <a:t>• Production-Grade Gemini UI: Real-time execution streaming, interactive checklist, and exports</a:t>
             </a:r>
           </a:p>
         </p:txBody>
@@ -3277,6 +3242,14 @@
 <file path=ppt/slides/slide2.xml><?xml version="1.0" encoding="utf-8"?>
 <p:sld xmlns:a="http://schemas.openxmlformats.org/drawingml/2006/main" xmlns:p="http://schemas.openxmlformats.org/presentationml/2006/main" xmlns:r="http://schemas.openxmlformats.org/officeDocument/2006/relationships">
   <p:cSld>
+    <p:bg>
+      <p:bgPr>
+        <a:solidFill>
+          <a:srgbClr val="131314"/>
+        </a:solidFill>
+        <a:effectLst/>
+      </p:bgPr>
+    </p:bg>
     <p:spTree>
       <p:nvGrpSpPr>
         <p:cNvPr id="1" name=""/>
@@ -3286,57 +3259,14 @@
       <p:grpSpPr/>
       <p:sp>
         <p:nvSpPr>
-          <p:cNvPr id="2" name="Rectangle 1"/>
-          <p:cNvSpPr/>
+          <p:cNvPr id="2" name="TextBox 1"/>
+          <p:cNvSpPr txBox="1"/>
           <p:nvPr/>
         </p:nvSpPr>
         <p:spPr>
           <a:xfrm>
-            <a:off x="0" y="0"/>
-            <a:ext cx="12191695" cy="6858000"/>
-          </a:xfrm>
-          <a:prstGeom prst="rect">
-            <a:avLst/>
-          </a:prstGeom>
-          <a:solidFill>
-            <a:srgbClr val="FAFAFC"/>
-          </a:solidFill>
-          <a:ln>
-            <a:noFill/>
-          </a:ln>
-        </p:spPr>
-        <p:style>
-          <a:lnRef idx="1">
-            <a:schemeClr val="accent1"/>
-          </a:lnRef>
-          <a:fillRef idx="3">
-            <a:schemeClr val="accent1"/>
-          </a:fillRef>
-          <a:effectRef idx="2">
-            <a:schemeClr val="accent1"/>
-          </a:effectRef>
-          <a:fontRef idx="minor">
-            <a:schemeClr val="lt1"/>
-          </a:fontRef>
-        </p:style>
-        <p:txBody>
-          <a:bodyPr rtlCol="0" anchor="ctr"/>
-          <a:lstStyle/>
-          <a:p>
-            <a:pPr algn="ctr"/>
-          </a:p>
-        </p:txBody>
-      </p:sp>
-      <p:sp>
-        <p:nvSpPr>
-          <p:cNvPr id="3" name="TextBox 2"/>
-          <p:cNvSpPr txBox="1"/>
-          <p:nvPr/>
-        </p:nvSpPr>
-        <p:spPr>
-          <a:xfrm>
-            <a:off x="731520" y="457200"/>
-            <a:ext cx="10698480" cy="365760"/>
+            <a:off x="731520" y="731520"/>
+            <a:ext cx="10698480" cy="1097280"/>
           </a:xfrm>
           <a:prstGeom prst="rect">
             <a:avLst/>
@@ -3350,28 +3280,40 @@
           <a:lstStyle/>
           <a:p>
             <a:pPr>
-              <a:defRPr sz="1100" b="1">
-                <a:solidFill>
-                  <a:srgbClr val="DC2626"/>
+              <a:defRPr sz="3600" b="1">
+                <a:solidFill>
+                  <a:srgbClr val="4285F4"/>
                 </a:solidFill>
               </a:defRPr>
             </a:pPr>
             <a:r>
-              <a:t>01 / CONTEXT &amp; PROBLEM</a:t>
-            </a:r>
-          </a:p>
-        </p:txBody>
-      </p:sp>
-      <p:sp>
-        <p:nvSpPr>
-          <p:cNvPr id="4" name="TextBox 3"/>
+              <a:t>Problem Statement &amp; Why One-Shot LLMs Fail</a:t>
+            </a:r>
+          </a:p>
+          <a:p>
+            <a:pPr>
+              <a:defRPr sz="1800">
+                <a:solidFill>
+                  <a:srgbClr val="8E918F"/>
+                </a:solidFill>
+              </a:defRPr>
+            </a:pPr>
+            <a:r>
+              <a:t>Moving from Superficial Prompting to True Autonomous Agentic Behavior</a:t>
+            </a:r>
+          </a:p>
+        </p:txBody>
+      </p:sp>
+      <p:sp>
+        <p:nvSpPr>
+          <p:cNvPr id="3" name="TextBox 2"/>
           <p:cNvSpPr txBox="1"/>
           <p:nvPr/>
         </p:nvSpPr>
         <p:spPr>
           <a:xfrm>
-            <a:off x="731520" y="731520"/>
-            <a:ext cx="10698480" cy="731520"/>
+            <a:off x="731520" y="2011680"/>
+            <a:ext cx="10698480" cy="4114800"/>
           </a:xfrm>
           <a:prstGeom prst="rect">
             <a:avLst/>
@@ -3383,250 +3325,65 @@
             <a:spAutoFit/>
           </a:bodyPr>
           <a:lstStyle/>
-          <a:p>
-            <a:pPr>
-              <a:defRPr sz="2600" b="1">
-                <a:solidFill>
-                  <a:srgbClr val="0F172A"/>
-                </a:solidFill>
-              </a:defRPr>
-            </a:pPr>
-            <a:r>
-              <a:t>The Problem: Why Unstructured Goals Fail in One-Shot Prompting</a:t>
-            </a:r>
-          </a:p>
-        </p:txBody>
-      </p:sp>
-      <p:sp>
-        <p:nvSpPr>
-          <p:cNvPr id="5" name="Rounded Rectangle 4"/>
-          <p:cNvSpPr/>
-          <p:nvPr/>
-        </p:nvSpPr>
-        <p:spPr>
-          <a:xfrm>
-            <a:off x="731520" y="1645920"/>
-            <a:ext cx="5120640" cy="4389120"/>
-          </a:xfrm>
-          <a:prstGeom prst="roundRect">
-            <a:avLst/>
-          </a:prstGeom>
-          <a:solidFill>
-            <a:srgbClr val="FFFFFF"/>
-          </a:solidFill>
-          <a:ln>
-            <a:solidFill>
-              <a:srgbClr val="DC2626"/>
-            </a:solidFill>
-          </a:ln>
-        </p:spPr>
-        <p:style>
-          <a:lnRef idx="1">
-            <a:schemeClr val="accent1"/>
-          </a:lnRef>
-          <a:fillRef idx="3">
-            <a:schemeClr val="accent1"/>
-          </a:fillRef>
-          <a:effectRef idx="2">
-            <a:schemeClr val="accent1"/>
-          </a:effectRef>
-          <a:fontRef idx="minor">
-            <a:schemeClr val="lt1"/>
-          </a:fontRef>
-        </p:style>
-        <p:txBody>
-          <a:bodyPr rtlCol="0" anchor="ctr" wrap="square"/>
-          <a:lstStyle/>
-          <a:p>
-            <a:pPr algn="ctr">
-              <a:spcAft>
-                <a:spcPts val="1200"/>
-              </a:spcAft>
-              <a:defRPr sz="1800" b="1">
-                <a:solidFill>
-                  <a:srgbClr val="DC2626"/>
-                </a:solidFill>
-              </a:defRPr>
-            </a:pPr>
-            <a:r>
-              <a:t>❌ One-Shot LLM Text Generation</a:t>
-            </a:r>
-          </a:p>
+          <a:p/>
           <a:p>
             <a:pPr>
               <a:spcAft>
-                <a:spcPts val="1000"/>
+                <a:spcPts val="1800"/>
               </a:spcAft>
-              <a:defRPr sz="1300">
-                <a:solidFill>
-                  <a:srgbClr val="0F172A"/>
+              <a:defRPr sz="2000">
+                <a:solidFill>
+                  <a:srgbClr val="F0F4F9"/>
                 </a:solidFill>
               </a:defRPr>
             </a:pPr>
             <a:r>
-              <a:t>• Unstructured Paragraph Dumps: Produces vague essays lacking sequential order, timestamps, or milestone checkpoints.</a:t>
+              <a:t>• The Failure of Single-Shot LLMs: Generates static bullet lists without budget verification or currency checks.</a:t>
             </a:r>
           </a:p>
           <a:p>
             <a:pPr>
               <a:spcAft>
-                <a:spcPts val="1000"/>
+                <a:spcPts val="1800"/>
               </a:spcAft>
-              <a:defRPr sz="1300">
-                <a:solidFill>
-                  <a:srgbClr val="0F172A"/>
+              <a:defRPr sz="2000">
+                <a:solidFill>
+                  <a:srgbClr val="F0F4F9"/>
                 </a:solidFill>
               </a:defRPr>
             </a:pPr>
             <a:r>
-              <a:t>• Zero Constraint Verification: Never calculates whether a stated budget or timeline can realistically cover execution.</a:t>
+              <a:t>• Zero Financial Constraints: Traditional LLMs cannot guarantee that line items stay within budget caps.</a:t>
             </a:r>
           </a:p>
           <a:p>
             <a:pPr>
               <a:spcAft>
-                <a:spcPts val="1000"/>
+                <a:spcPts val="1800"/>
               </a:spcAft>
-              <a:defRPr sz="1300">
-                <a:solidFill>
-                  <a:srgbClr val="0F172A"/>
+              <a:defRPr sz="2000">
+                <a:solidFill>
+                  <a:srgbClr val="F0F4F9"/>
                 </a:solidFill>
               </a:defRPr>
             </a:pPr>
             <a:r>
-              <a:t>• Blind to Dependency Blockers: Schedules downstream actions before prerequisites are confirmed (e.g. touring before transit).</a:t>
+              <a:t>• The Solution: Multi-step ReAct pattern where the agent uses computational tools to verify every number.</a:t>
             </a:r>
           </a:p>
           <a:p>
             <a:pPr>
               <a:spcAft>
-                <a:spcPts val="1000"/>
+                <a:spcPts val="1800"/>
               </a:spcAft>
-              <a:defRPr sz="1300">
-                <a:solidFill>
-                  <a:srgbClr val="0F172A"/>
+              <a:defRPr sz="2000">
+                <a:solidFill>
+                  <a:srgbClr val="F0F4F9"/>
                 </a:solidFill>
               </a:defRPr>
             </a:pPr>
             <a:r>
-              <a:t>• Rigid Static Templates: Brittle bots fail when user input diverges from hardcoded topics.</a:t>
-            </a:r>
-          </a:p>
-        </p:txBody>
-      </p:sp>
-      <p:sp>
-        <p:nvSpPr>
-          <p:cNvPr id="6" name="Rounded Rectangle 5"/>
-          <p:cNvSpPr/>
-          <p:nvPr/>
-        </p:nvSpPr>
-        <p:spPr>
-          <a:xfrm>
-            <a:off x="6217920" y="1645920"/>
-            <a:ext cx="5212080" cy="4389120"/>
-          </a:xfrm>
-          <a:prstGeom prst="roundRect">
-            <a:avLst/>
-          </a:prstGeom>
-          <a:solidFill>
-            <a:srgbClr val="FFFFFF"/>
-          </a:solidFill>
-          <a:ln>
-            <a:solidFill>
-              <a:srgbClr val="E2E8F0"/>
-            </a:solidFill>
-          </a:ln>
-        </p:spPr>
-        <p:style>
-          <a:lnRef idx="1">
-            <a:schemeClr val="accent1"/>
-          </a:lnRef>
-          <a:fillRef idx="3">
-            <a:schemeClr val="accent1"/>
-          </a:fillRef>
-          <a:effectRef idx="2">
-            <a:schemeClr val="accent1"/>
-          </a:effectRef>
-          <a:fontRef idx="minor">
-            <a:schemeClr val="lt1"/>
-          </a:fontRef>
-        </p:style>
-        <p:txBody>
-          <a:bodyPr rtlCol="0" anchor="ctr" wrap="square"/>
-          <a:lstStyle/>
-          <a:p>
-            <a:pPr algn="ctr">
-              <a:spcAft>
-                <a:spcPts val="1200"/>
-              </a:spcAft>
-              <a:defRPr sz="1800" b="1">
-                <a:solidFill>
-                  <a:srgbClr val="991B1B"/>
-                </a:solidFill>
-              </a:defRPr>
-            </a:pPr>
-            <a:r>
-              <a:t>✅ Universal Task Planner Solution</a:t>
-            </a:r>
-          </a:p>
-          <a:p>
-            <a:pPr>
-              <a:spcAft>
-                <a:spcPts val="1000"/>
-              </a:spcAft>
-              <a:defRPr sz="1300">
-                <a:solidFill>
-                  <a:srgbClr val="0F172A"/>
-                </a:solidFill>
-              </a:defRPr>
-            </a:pPr>
-            <a:r>
-              <a:t>• Universal Goal Deconstruction: Dynamically analyzes ANY task or prompt without being restricted to pre-baked plans.</a:t>
-            </a:r>
-          </a:p>
-          <a:p>
-            <a:pPr>
-              <a:spcAft>
-                <a:spcPts val="1000"/>
-              </a:spcAft>
-              <a:defRPr sz="1300">
-                <a:solidFill>
-                  <a:srgbClr val="0F172A"/>
-                </a:solidFill>
-              </a:defRPr>
-            </a:pPr>
-            <a:r>
-              <a:t>• Phased Sub-Task Matrix: Generates discrete, numbered subtasks with duration estimates and explicit deliverables.</a:t>
-            </a:r>
-          </a:p>
-          <a:p>
-            <a:pPr>
-              <a:spcAft>
-                <a:spcPts val="1000"/>
-              </a:spcAft>
-              <a:defRPr sz="1300">
-                <a:solidFill>
-                  <a:srgbClr val="0F172A"/>
-                </a:solidFill>
-              </a:defRPr>
-            </a:pPr>
-            <a:r>
-              <a:t>• Feasibility Auditing: Tests timeline and budget limits against operational benchmarks with feasibility scoring (0-100).</a:t>
-            </a:r>
-          </a:p>
-          <a:p>
-            <a:pPr>
-              <a:spcAft>
-                <a:spcPts val="1000"/>
-              </a:spcAft>
-              <a:defRPr sz="1300">
-                <a:solidFill>
-                  <a:srgbClr val="0F172A"/>
-                </a:solidFill>
-              </a:defRPr>
-            </a:pPr>
-            <a:r>
-              <a:t>• Critical Path &amp; Risk Guardrails: Maps sequential bottleneck chains and injects automated contingency safeguards.</a:t>
+              <a:t>• Feasibility Index: Calculates mathematical feasibility and safeguards contingency funds against unexpected spikes.</a:t>
             </a:r>
           </a:p>
         </p:txBody>
@@ -3642,6 +3399,14 @@
 <file path=ppt/slides/slide3.xml><?xml version="1.0" encoding="utf-8"?>
 <p:sld xmlns:a="http://schemas.openxmlformats.org/drawingml/2006/main" xmlns:p="http://schemas.openxmlformats.org/presentationml/2006/main" xmlns:r="http://schemas.openxmlformats.org/officeDocument/2006/relationships">
   <p:cSld>
+    <p:bg>
+      <p:bgPr>
+        <a:solidFill>
+          <a:srgbClr val="131314"/>
+        </a:solidFill>
+        <a:effectLst/>
+      </p:bgPr>
+    </p:bg>
     <p:spTree>
       <p:nvGrpSpPr>
         <p:cNvPr id="1" name=""/>
@@ -3651,57 +3416,14 @@
       <p:grpSpPr/>
       <p:sp>
         <p:nvSpPr>
-          <p:cNvPr id="2" name="Rectangle 1"/>
-          <p:cNvSpPr/>
+          <p:cNvPr id="2" name="TextBox 1"/>
+          <p:cNvSpPr txBox="1"/>
           <p:nvPr/>
         </p:nvSpPr>
         <p:spPr>
           <a:xfrm>
-            <a:off x="0" y="0"/>
-            <a:ext cx="12191695" cy="6858000"/>
-          </a:xfrm>
-          <a:prstGeom prst="rect">
-            <a:avLst/>
-          </a:prstGeom>
-          <a:solidFill>
-            <a:srgbClr val="FAFAFC"/>
-          </a:solidFill>
-          <a:ln>
-            <a:noFill/>
-          </a:ln>
-        </p:spPr>
-        <p:style>
-          <a:lnRef idx="1">
-            <a:schemeClr val="accent1"/>
-          </a:lnRef>
-          <a:fillRef idx="3">
-            <a:schemeClr val="accent1"/>
-          </a:fillRef>
-          <a:effectRef idx="2">
-            <a:schemeClr val="accent1"/>
-          </a:effectRef>
-          <a:fontRef idx="minor">
-            <a:schemeClr val="lt1"/>
-          </a:fontRef>
-        </p:style>
-        <p:txBody>
-          <a:bodyPr rtlCol="0" anchor="ctr"/>
-          <a:lstStyle/>
-          <a:p>
-            <a:pPr algn="ctr"/>
-          </a:p>
-        </p:txBody>
-      </p:sp>
-      <p:sp>
-        <p:nvSpPr>
-          <p:cNvPr id="3" name="TextBox 2"/>
-          <p:cNvSpPr txBox="1"/>
-          <p:nvPr/>
-        </p:nvSpPr>
-        <p:spPr>
-          <a:xfrm>
-            <a:off x="731520" y="457200"/>
-            <a:ext cx="10698480" cy="365760"/>
+            <a:off x="731520" y="731520"/>
+            <a:ext cx="10698480" cy="1097280"/>
           </a:xfrm>
           <a:prstGeom prst="rect">
             <a:avLst/>
@@ -3715,28 +3437,40 @@
           <a:lstStyle/>
           <a:p>
             <a:pPr>
-              <a:defRPr sz="1100" b="1">
-                <a:solidFill>
-                  <a:srgbClr val="DC2626"/>
+              <a:defRPr sz="3600" b="1">
+                <a:solidFill>
+                  <a:srgbClr val="4285F4"/>
                 </a:solidFill>
               </a:defRPr>
             </a:pPr>
             <a:r>
-              <a:t>02 / ARCHITECTURE &amp; FLOW</a:t>
-            </a:r>
-          </a:p>
-        </p:txBody>
-      </p:sp>
-      <p:sp>
-        <p:nvSpPr>
-          <p:cNvPr id="4" name="TextBox 3"/>
+              <a:t>System Architecture &amp; The 5-Stage ReAct Loop</a:t>
+            </a:r>
+          </a:p>
+          <a:p>
+            <a:pPr>
+              <a:defRPr sz="1800">
+                <a:solidFill>
+                  <a:srgbClr val="8E918F"/>
+                </a:solidFill>
+              </a:defRPr>
+            </a:pPr>
+            <a:r>
+              <a:t>Transparent Execution Pipeline with Real-Time Server-Sent Events (SSE)</a:t>
+            </a:r>
+          </a:p>
+        </p:txBody>
+      </p:sp>
+      <p:sp>
+        <p:nvSpPr>
+          <p:cNvPr id="3" name="TextBox 2"/>
           <p:cNvSpPr txBox="1"/>
           <p:nvPr/>
         </p:nvSpPr>
         <p:spPr>
           <a:xfrm>
-            <a:off x="731520" y="731520"/>
-            <a:ext cx="10698480" cy="731520"/>
+            <a:off x="731520" y="2011680"/>
+            <a:ext cx="10698480" cy="4114800"/>
           </a:xfrm>
           <a:prstGeom prst="rect">
             <a:avLst/>
@@ -3748,352 +3482,80 @@
             <a:spAutoFit/>
           </a:bodyPr>
           <a:lstStyle/>
-          <a:p>
-            <a:pPr>
-              <a:defRPr sz="2600" b="1">
-                <a:solidFill>
-                  <a:srgbClr val="0F172A"/>
-                </a:solidFill>
-              </a:defRPr>
-            </a:pPr>
-            <a:r>
-              <a:t>System Architecture: Plan → Act → Observe → Respond</a:t>
-            </a:r>
-          </a:p>
-        </p:txBody>
-      </p:sp>
-      <p:sp>
-        <p:nvSpPr>
-          <p:cNvPr id="5" name="Rounded Rectangle 4"/>
-          <p:cNvSpPr/>
-          <p:nvPr/>
-        </p:nvSpPr>
-        <p:spPr>
-          <a:xfrm>
-            <a:off x="731520" y="1645920"/>
-            <a:ext cx="2560320" cy="4389120"/>
-          </a:xfrm>
-          <a:prstGeom prst="roundRect">
-            <a:avLst/>
-          </a:prstGeom>
-          <a:solidFill>
-            <a:srgbClr val="FFFFFF"/>
-          </a:solidFill>
-          <a:ln>
-            <a:solidFill>
-              <a:srgbClr val="DC2626"/>
-            </a:solidFill>
-          </a:ln>
-        </p:spPr>
-        <p:style>
-          <a:lnRef idx="1">
-            <a:schemeClr val="accent1"/>
-          </a:lnRef>
-          <a:fillRef idx="3">
-            <a:schemeClr val="accent1"/>
-          </a:fillRef>
-          <a:effectRef idx="2">
-            <a:schemeClr val="accent1"/>
-          </a:effectRef>
-          <a:fontRef idx="minor">
-            <a:schemeClr val="lt1"/>
-          </a:fontRef>
-        </p:style>
-        <p:txBody>
-          <a:bodyPr rtlCol="0" anchor="ctr" wrap="square"/>
-          <a:lstStyle/>
-          <a:p>
-            <a:pPr algn="ctr">
-              <a:spcAft>
-                <a:spcPts val="600"/>
-              </a:spcAft>
-              <a:defRPr sz="1600" b="1">
-                <a:solidFill>
-                  <a:srgbClr val="DC2626"/>
-                </a:solidFill>
-              </a:defRPr>
-            </a:pPr>
-            <a:r>
-              <a:t>1. PLAN</a:t>
-            </a:r>
-          </a:p>
+          <a:p/>
           <a:p>
             <a:pPr>
               <a:spcAft>
-                <a:spcPts val="1000"/>
+                <a:spcPts val="1800"/>
               </a:spcAft>
-              <a:defRPr sz="1300" b="1">
-                <a:solidFill>
-                  <a:srgbClr val="0F172A"/>
+              <a:defRPr sz="2000">
+                <a:solidFill>
+                  <a:srgbClr val="F0F4F9"/>
                 </a:solidFill>
               </a:defRPr>
             </a:pPr>
             <a:r>
-              <a:t>Task Intent Parsing</a:t>
-            </a:r>
-          </a:p>
-          <a:p>
-            <a:pPr>
-              <a:defRPr sz="1200">
-                <a:solidFill>
-                  <a:srgbClr val="64748B"/>
-                </a:solidFill>
-              </a:defRPr>
-            </a:pPr>
-            <a:r>
-              <a:t>Extracts primary objective, numerical timeline, budget ceiling, and complexity tier for ANY goal.</a:t>
-            </a:r>
-          </a:p>
-        </p:txBody>
-      </p:sp>
-      <p:sp>
-        <p:nvSpPr>
-          <p:cNvPr id="6" name="Rounded Rectangle 5"/>
-          <p:cNvSpPr/>
-          <p:nvPr/>
-        </p:nvSpPr>
-        <p:spPr>
-          <a:xfrm>
-            <a:off x="3429000" y="1645920"/>
-            <a:ext cx="2560320" cy="4389120"/>
-          </a:xfrm>
-          <a:prstGeom prst="roundRect">
-            <a:avLst/>
-          </a:prstGeom>
-          <a:solidFill>
-            <a:srgbClr val="FFFFFF"/>
-          </a:solidFill>
-          <a:ln>
-            <a:solidFill>
-              <a:srgbClr val="E2E8F0"/>
-            </a:solidFill>
-          </a:ln>
-        </p:spPr>
-        <p:style>
-          <a:lnRef idx="1">
-            <a:schemeClr val="accent1"/>
-          </a:lnRef>
-          <a:fillRef idx="3">
-            <a:schemeClr val="accent1"/>
-          </a:fillRef>
-          <a:effectRef idx="2">
-            <a:schemeClr val="accent1"/>
-          </a:effectRef>
-          <a:fontRef idx="minor">
-            <a:schemeClr val="lt1"/>
-          </a:fontRef>
-        </p:style>
-        <p:txBody>
-          <a:bodyPr rtlCol="0" anchor="ctr" wrap="square"/>
-          <a:lstStyle/>
-          <a:p>
-            <a:pPr algn="ctr">
-              <a:spcAft>
-                <a:spcPts val="600"/>
-              </a:spcAft>
-              <a:defRPr sz="1600" b="1">
-                <a:solidFill>
-                  <a:srgbClr val="DC2626"/>
-                </a:solidFill>
-              </a:defRPr>
-            </a:pPr>
-            <a:r>
-              <a:t>2. ACT</a:t>
+              <a:t>• 1. PLAN: Deconstructs user intent, classifies domain, and extracts budget &amp; currency parameters.</a:t>
             </a:r>
           </a:p>
           <a:p>
             <a:pPr>
               <a:spcAft>
-                <a:spcPts val="1000"/>
+                <a:spcPts val="1800"/>
               </a:spcAft>
-              <a:defRPr sz="1300" b="1">
-                <a:solidFill>
-                  <a:srgbClr val="0F172A"/>
+              <a:defRPr sz="2000">
+                <a:solidFill>
+                  <a:srgbClr val="F0F4F9"/>
                 </a:solidFill>
               </a:defRPr>
             </a:pPr>
             <a:r>
-              <a:t>Universal Tool Invocations</a:t>
-            </a:r>
-          </a:p>
-          <a:p>
-            <a:pPr>
-              <a:defRPr sz="1200">
-                <a:solidFill>
-                  <a:srgbClr val="64748B"/>
-                </a:solidFill>
-              </a:defRPr>
-            </a:pPr>
-            <a:r>
-              <a:t>Calls specialized tools: intent analyzer, feasibility auditor, subtask decomposer, critical path scheduler.</a:t>
-            </a:r>
-          </a:p>
-        </p:txBody>
-      </p:sp>
-      <p:sp>
-        <p:nvSpPr>
-          <p:cNvPr id="7" name="Rounded Rectangle 6"/>
-          <p:cNvSpPr/>
-          <p:nvPr/>
-        </p:nvSpPr>
-        <p:spPr>
-          <a:xfrm>
-            <a:off x="6126480" y="1645920"/>
-            <a:ext cx="2560320" cy="4389120"/>
-          </a:xfrm>
-          <a:prstGeom prst="roundRect">
-            <a:avLst/>
-          </a:prstGeom>
-          <a:solidFill>
-            <a:srgbClr val="FFFFFF"/>
-          </a:solidFill>
-          <a:ln>
-            <a:solidFill>
-              <a:srgbClr val="E2E8F0"/>
-            </a:solidFill>
-          </a:ln>
-        </p:spPr>
-        <p:style>
-          <a:lnRef idx="1">
-            <a:schemeClr val="accent1"/>
-          </a:lnRef>
-          <a:fillRef idx="3">
-            <a:schemeClr val="accent1"/>
-          </a:fillRef>
-          <a:effectRef idx="2">
-            <a:schemeClr val="accent1"/>
-          </a:effectRef>
-          <a:fontRef idx="minor">
-            <a:schemeClr val="lt1"/>
-          </a:fontRef>
-        </p:style>
-        <p:txBody>
-          <a:bodyPr rtlCol="0" anchor="ctr" wrap="square"/>
-          <a:lstStyle/>
-          <a:p>
-            <a:pPr algn="ctr">
-              <a:spcAft>
-                <a:spcPts val="600"/>
-              </a:spcAft>
-              <a:defRPr sz="1600" b="1">
-                <a:solidFill>
-                  <a:srgbClr val="DC2626"/>
-                </a:solidFill>
-              </a:defRPr>
-            </a:pPr>
-            <a:r>
-              <a:t>3. OBSERVE</a:t>
+              <a:t>• 2. ACT: Executes 6 specialized tools (CurrencyConverter, BudgetCalculator, ScheduleEstimator, RiskEvaluator, ResourceFinder, KnowledgeRetriever).</a:t>
             </a:r>
           </a:p>
           <a:p>
             <a:pPr>
               <a:spcAft>
-                <a:spcPts val="1000"/>
+                <a:spcPts val="1800"/>
               </a:spcAft>
-              <a:defRPr sz="1300" b="1">
-                <a:solidFill>
-                  <a:srgbClr val="0F172A"/>
+              <a:defRPr sz="2000">
+                <a:solidFill>
+                  <a:srgbClr val="F0F4F9"/>
                 </a:solidFill>
               </a:defRPr>
             </a:pPr>
             <a:r>
-              <a:t>Telemetry Scratchpad</a:t>
-            </a:r>
-          </a:p>
-          <a:p>
-            <a:pPr>
-              <a:defRPr sz="1200">
-                <a:solidFill>
-                  <a:srgbClr val="64748B"/>
-                </a:solidFill>
-              </a:defRPr>
-            </a:pPr>
-            <a:r>
-              <a:t>Accumulates structured observations and constraint checks into Pydantic AgentState memory.</a:t>
-            </a:r>
-          </a:p>
-        </p:txBody>
-      </p:sp>
-      <p:sp>
-        <p:nvSpPr>
-          <p:cNvPr id="8" name="Rounded Rectangle 7"/>
-          <p:cNvSpPr/>
-          <p:nvPr/>
-        </p:nvSpPr>
-        <p:spPr>
-          <a:xfrm>
-            <a:off x="8823960" y="1645920"/>
-            <a:ext cx="2560320" cy="4389120"/>
-          </a:xfrm>
-          <a:prstGeom prst="roundRect">
-            <a:avLst/>
-          </a:prstGeom>
-          <a:solidFill>
-            <a:srgbClr val="FFFFFF"/>
-          </a:solidFill>
-          <a:ln>
-            <a:solidFill>
-              <a:srgbClr val="DC2626"/>
-            </a:solidFill>
-          </a:ln>
-        </p:spPr>
-        <p:style>
-          <a:lnRef idx="1">
-            <a:schemeClr val="accent1"/>
-          </a:lnRef>
-          <a:fillRef idx="3">
-            <a:schemeClr val="accent1"/>
-          </a:fillRef>
-          <a:effectRef idx="2">
-            <a:schemeClr val="accent1"/>
-          </a:effectRef>
-          <a:fontRef idx="minor">
-            <a:schemeClr val="lt1"/>
-          </a:fontRef>
-        </p:style>
-        <p:txBody>
-          <a:bodyPr rtlCol="0" anchor="ctr" wrap="square"/>
-          <a:lstStyle/>
-          <a:p>
-            <a:pPr algn="ctr">
-              <a:spcAft>
-                <a:spcPts val="600"/>
-              </a:spcAft>
-              <a:defRPr sz="1600" b="1">
-                <a:solidFill>
-                  <a:srgbClr val="DC2626"/>
-                </a:solidFill>
-              </a:defRPr>
-            </a:pPr>
-            <a:r>
-              <a:t>4. RESPOND</a:t>
+              <a:t>• 3. OBSERVE: Validates financial feasibility, checks constraints, and assesses risk probability/impact.</a:t>
             </a:r>
           </a:p>
           <a:p>
             <a:pPr>
               <a:spcAft>
-                <a:spcPts val="1000"/>
+                <a:spcPts val="1800"/>
               </a:spcAft>
-              <a:defRPr sz="1300" b="1">
-                <a:solidFill>
-                  <a:srgbClr val="0F172A"/>
+              <a:defRPr sz="2000">
+                <a:solidFill>
+                  <a:srgbClr val="F0F4F9"/>
                 </a:solidFill>
               </a:defRPr>
             </a:pPr>
             <a:r>
-              <a:t>Master Plan Synthesis</a:t>
+              <a:t>• 4. ADJUST: Rebalances phase allocations, resolves dependency sequencing, and tags priorities.</a:t>
             </a:r>
           </a:p>
           <a:p>
             <a:pPr>
-              <a:defRPr sz="1200">
-                <a:solidFill>
-                  <a:srgbClr val="64748B"/>
+              <a:spcAft>
+                <a:spcPts val="1800"/>
+              </a:spcAft>
+              <a:defRPr sz="2000">
+                <a:solidFill>
+                  <a:srgbClr val="F0F4F9"/>
                 </a:solidFill>
               </a:defRPr>
             </a:pPr>
             <a:r>
-              <a:t>Compiles phase matrix, milestone timeline, risk safeguards, and persists plan with unique Plan ID.</a:t>
+              <a:t>• 5. RESPOND: Synthesizes final actionable plan and streams execution steps live to the client.</a:t>
             </a:r>
           </a:p>
         </p:txBody>
@@ -4109,6 +3571,14 @@
 <file path=ppt/slides/slide4.xml><?xml version="1.0" encoding="utf-8"?>
 <p:sld xmlns:a="http://schemas.openxmlformats.org/drawingml/2006/main" xmlns:p="http://schemas.openxmlformats.org/presentationml/2006/main" xmlns:r="http://schemas.openxmlformats.org/officeDocument/2006/relationships">
   <p:cSld>
+    <p:bg>
+      <p:bgPr>
+        <a:solidFill>
+          <a:srgbClr val="131314"/>
+        </a:solidFill>
+        <a:effectLst/>
+      </p:bgPr>
+    </p:bg>
     <p:spTree>
       <p:nvGrpSpPr>
         <p:cNvPr id="1" name=""/>
@@ -4118,57 +3588,14 @@
       <p:grpSpPr/>
       <p:sp>
         <p:nvSpPr>
-          <p:cNvPr id="2" name="Rectangle 1"/>
-          <p:cNvSpPr/>
+          <p:cNvPr id="2" name="TextBox 1"/>
+          <p:cNvSpPr txBox="1"/>
           <p:nvPr/>
         </p:nvSpPr>
         <p:spPr>
           <a:xfrm>
-            <a:off x="0" y="0"/>
-            <a:ext cx="12191695" cy="6858000"/>
-          </a:xfrm>
-          <a:prstGeom prst="rect">
-            <a:avLst/>
-          </a:prstGeom>
-          <a:solidFill>
-            <a:srgbClr val="FAFAFC"/>
-          </a:solidFill>
-          <a:ln>
-            <a:noFill/>
-          </a:ln>
-        </p:spPr>
-        <p:style>
-          <a:lnRef idx="1">
-            <a:schemeClr val="accent1"/>
-          </a:lnRef>
-          <a:fillRef idx="3">
-            <a:schemeClr val="accent1"/>
-          </a:fillRef>
-          <a:effectRef idx="2">
-            <a:schemeClr val="accent1"/>
-          </a:effectRef>
-          <a:fontRef idx="minor">
-            <a:schemeClr val="lt1"/>
-          </a:fontRef>
-        </p:style>
-        <p:txBody>
-          <a:bodyPr rtlCol="0" anchor="ctr"/>
-          <a:lstStyle/>
-          <a:p>
-            <a:pPr algn="ctr"/>
-          </a:p>
-        </p:txBody>
-      </p:sp>
-      <p:sp>
-        <p:nvSpPr>
-          <p:cNvPr id="3" name="TextBox 2"/>
-          <p:cNvSpPr txBox="1"/>
-          <p:nvPr/>
-        </p:nvSpPr>
-        <p:spPr>
-          <a:xfrm>
-            <a:off x="731520" y="457200"/>
-            <a:ext cx="10698480" cy="365760"/>
+            <a:off x="731520" y="731520"/>
+            <a:ext cx="10698480" cy="1097280"/>
           </a:xfrm>
           <a:prstGeom prst="rect">
             <a:avLst/>
@@ -4182,28 +3609,40 @@
           <a:lstStyle/>
           <a:p>
             <a:pPr>
-              <a:defRPr sz="1100" b="1">
-                <a:solidFill>
-                  <a:srgbClr val="DC2626"/>
+              <a:defRPr sz="3600" b="1">
+                <a:solidFill>
+                  <a:srgbClr val="4285F4"/>
                 </a:solidFill>
               </a:defRPr>
             </a:pPr>
             <a:r>
-              <a:t>03 / TOOL SUITE &amp; BENCHMARKS</a:t>
-            </a:r>
-          </a:p>
-        </p:txBody>
-      </p:sp>
-      <p:sp>
-        <p:nvSpPr>
-          <p:cNvPr id="4" name="TextBox 3"/>
+              <a:t>Multi-Currency &amp; Financial Feasibility Engine</a:t>
+            </a:r>
+          </a:p>
+          <a:p>
+            <a:pPr>
+              <a:defRPr sz="1800">
+                <a:solidFill>
+                  <a:srgbClr val="8E918F"/>
+                </a:solidFill>
+              </a:defRPr>
+            </a:pPr>
+            <a:r>
+              <a:t>Strict Budget Control in Any Currency with Zero Debt Risk</a:t>
+            </a:r>
+          </a:p>
+        </p:txBody>
+      </p:sp>
+      <p:sp>
+        <p:nvSpPr>
+          <p:cNvPr id="3" name="TextBox 2"/>
           <p:cNvSpPr txBox="1"/>
           <p:nvPr/>
         </p:nvSpPr>
         <p:spPr>
           <a:xfrm>
-            <a:off x="731520" y="731520"/>
-            <a:ext cx="10698480" cy="731520"/>
+            <a:off x="731520" y="2011680"/>
+            <a:ext cx="10698480" cy="4114800"/>
           </a:xfrm>
           <a:prstGeom prst="rect">
             <a:avLst/>
@@ -4215,295 +3654,65 @@
             <a:spAutoFit/>
           </a:bodyPr>
           <a:lstStyle/>
-          <a:p>
-            <a:pPr>
-              <a:defRPr sz="2600" b="1">
-                <a:solidFill>
-                  <a:srgbClr val="0F172A"/>
-                </a:solidFill>
-              </a:defRPr>
-            </a:pPr>
-            <a:r>
-              <a:t>Universal Tool Suite &amp; Multi-Domain Planning Capabilities</a:t>
-            </a:r>
-          </a:p>
-        </p:txBody>
-      </p:sp>
-      <p:sp>
-        <p:nvSpPr>
-          <p:cNvPr id="5" name="Rounded Rectangle 4"/>
-          <p:cNvSpPr/>
-          <p:nvPr/>
-        </p:nvSpPr>
-        <p:spPr>
-          <a:xfrm>
-            <a:off x="731520" y="1645920"/>
-            <a:ext cx="5120640" cy="4389120"/>
-          </a:xfrm>
-          <a:prstGeom prst="roundRect">
-            <a:avLst/>
-          </a:prstGeom>
-          <a:solidFill>
-            <a:srgbClr val="FFFFFF"/>
-          </a:solidFill>
-          <a:ln>
-            <a:solidFill>
-              <a:srgbClr val="E2E8F0"/>
-            </a:solidFill>
-          </a:ln>
-        </p:spPr>
-        <p:style>
-          <a:lnRef idx="1">
-            <a:schemeClr val="accent1"/>
-          </a:lnRef>
-          <a:fillRef idx="3">
-            <a:schemeClr val="accent1"/>
-          </a:fillRef>
-          <a:effectRef idx="2">
-            <a:schemeClr val="accent1"/>
-          </a:effectRef>
-          <a:fontRef idx="minor">
-            <a:schemeClr val="lt1"/>
-          </a:fontRef>
-        </p:style>
-        <p:txBody>
-          <a:bodyPr rtlCol="0" anchor="ctr" wrap="square"/>
-          <a:lstStyle/>
-          <a:p>
-            <a:pPr algn="ctr">
-              <a:spcAft>
-                <a:spcPts val="1000"/>
-              </a:spcAft>
-              <a:defRPr sz="1800" b="1">
-                <a:solidFill>
-                  <a:srgbClr val="DC2626"/>
-                </a:solidFill>
-              </a:defRPr>
-            </a:pPr>
-            <a:r>
-              <a:t>🛠️ Autonomous Planning Tools</a:t>
-            </a:r>
-          </a:p>
+          <a:p/>
           <a:p>
             <a:pPr>
               <a:spcAft>
-                <a:spcPts val="600"/>
+                <a:spcPts val="1800"/>
               </a:spcAft>
-              <a:defRPr sz="1200">
-                <a:solidFill>
-                  <a:srgbClr val="0F172A"/>
+              <a:defRPr sz="2000">
+                <a:solidFill>
+                  <a:srgbClr val="F0F4F9"/>
                 </a:solidFill>
               </a:defRPr>
             </a:pPr>
             <a:r>
-              <a:t>• analyze_task_intent: Extracts goal intent, domain category, timeline constraints &amp; complexity.</a:t>
+              <a:t>• 35+ World Currencies Supported: USD ($), EUR (€), INR (₹), GBP (£), JPY (¥), CAD (C$), AUD (A$), AED, CHF, SGD, etc.</a:t>
             </a:r>
           </a:p>
           <a:p>
             <a:pPr>
               <a:spcAft>
-                <a:spcPts val="600"/>
+                <a:spcPts val="1800"/>
               </a:spcAft>
-              <a:defRPr sz="1200">
-                <a:solidFill>
-                  <a:srgbClr val="0F172A"/>
+              <a:defRPr sz="2000">
+                <a:solidFill>
+                  <a:srgbClr val="F0F4F9"/>
                 </a:solidFill>
               </a:defRPr>
             </a:pPr>
             <a:r>
-              <a:t>• audit_feasibility_and_effort: Computes workload hours, feasibility scores (0-100) &amp; bottlenecks.</a:t>
+              <a:t>• Dedicated 12% Contingency Buffer: Automatically set aside to protect against price volatility and fees.</a:t>
             </a:r>
           </a:p>
           <a:p>
             <a:pPr>
               <a:spcAft>
-                <a:spcPts val="600"/>
+                <a:spcPts val="1800"/>
               </a:spcAft>
-              <a:defRPr sz="1200">
-                <a:solidFill>
-                  <a:srgbClr val="0F172A"/>
+              <a:defRPr sz="2000">
+                <a:solidFill>
+                  <a:srgbClr val="F0F4F9"/>
                 </a:solidFill>
               </a:defRPr>
             </a:pPr>
             <a:r>
-              <a:t>• decompose_any_task: Universally breaks down any task into 4 phased, chronological deliverables.</a:t>
+              <a:t>• Phased Fund Allocation: Distributes deployable funds proportionally based on domain benchmarks.</a:t>
             </a:r>
           </a:p>
           <a:p>
             <a:pPr>
               <a:spcAft>
-                <a:spcPts val="600"/>
+                <a:spcPts val="1800"/>
               </a:spcAft>
-              <a:defRPr sz="1200">
-                <a:solidFill>
-                  <a:srgbClr val="0F172A"/>
+              <a:defRPr sz="2000">
+                <a:solidFill>
+                  <a:srgbClr val="F0F4F9"/>
                 </a:solidFill>
               </a:defRPr>
             </a:pPr>
             <a:r>
-              <a:t>• derive_critical_path_and_milestones: Calculates sequential critical paths &amp; 3 progress gates.</a:t>
-            </a:r>
-          </a:p>
-          <a:p>
-            <a:pPr>
-              <a:spcAft>
-                <a:spcPts val="600"/>
-              </a:spcAft>
-              <a:defRPr sz="1200">
-                <a:solidFill>
-                  <a:srgbClr val="0F172A"/>
-                </a:solidFill>
-              </a:defRPr>
-            </a:pPr>
-            <a:r>
-              <a:t>• audit_failure_modes_and_safeguards: Identifies operational risks &amp; automated mitigations.</a:t>
-            </a:r>
-          </a:p>
-          <a:p>
-            <a:pPr>
-              <a:spcAft>
-                <a:spcPts val="600"/>
-              </a:spcAft>
-              <a:defRPr sz="1200">
-                <a:solidFill>
-                  <a:srgbClr val="0F172A"/>
-                </a:solidFill>
-              </a:defRPr>
-            </a:pPr>
-            <a:r>
-              <a:t>• persist_master_plan: Archives compiled master plans into permanent JSON storage.</a:t>
-            </a:r>
-          </a:p>
-        </p:txBody>
-      </p:sp>
-      <p:sp>
-        <p:nvSpPr>
-          <p:cNvPr id="6" name="Rounded Rectangle 5"/>
-          <p:cNvSpPr/>
-          <p:nvPr/>
-        </p:nvSpPr>
-        <p:spPr>
-          <a:xfrm>
-            <a:off x="6217920" y="1645920"/>
-            <a:ext cx="5212080" cy="4389120"/>
-          </a:xfrm>
-          <a:prstGeom prst="roundRect">
-            <a:avLst/>
-          </a:prstGeom>
-          <a:solidFill>
-            <a:srgbClr val="FFFFFF"/>
-          </a:solidFill>
-          <a:ln>
-            <a:solidFill>
-              <a:srgbClr val="DC2626"/>
-            </a:solidFill>
-          </a:ln>
-        </p:spPr>
-        <p:style>
-          <a:lnRef idx="1">
-            <a:schemeClr val="accent1"/>
-          </a:lnRef>
-          <a:fillRef idx="3">
-            <a:schemeClr val="accent1"/>
-          </a:fillRef>
-          <a:effectRef idx="2">
-            <a:schemeClr val="accent1"/>
-          </a:effectRef>
-          <a:fontRef idx="minor">
-            <a:schemeClr val="lt1"/>
-          </a:fontRef>
-        </p:style>
-        <p:txBody>
-          <a:bodyPr rtlCol="0" anchor="ctr" wrap="square"/>
-          <a:lstStyle/>
-          <a:p>
-            <a:pPr algn="ctr">
-              <a:spcAft>
-                <a:spcPts val="1000"/>
-              </a:spcAft>
-              <a:defRPr sz="1800" b="1">
-                <a:solidFill>
-                  <a:srgbClr val="991B1B"/>
-                </a:solidFill>
-              </a:defRPr>
-            </a:pPr>
-            <a:r>
-              <a:t>🌐 Tested Across Diverse Domains</a:t>
-            </a:r>
-          </a:p>
-          <a:p>
-            <a:pPr>
-              <a:spcAft>
-                <a:spcPts val="600"/>
-              </a:spcAft>
-              <a:defRPr sz="1200">
-                <a:solidFill>
-                  <a:srgbClr val="0F172A"/>
-                </a:solidFill>
-              </a:defRPr>
-            </a:pPr>
-            <a:r>
-              <a:t>• Travel &amp; Trips: 'Plan a 3-day trip to Tokyo for 2 people on a $1,200 budget.' (Phased daily itinerary, transit &amp; lodging).</a:t>
-            </a:r>
-          </a:p>
-          <a:p>
-            <a:pPr>
-              <a:spcAft>
-                <a:spcPts val="600"/>
-              </a:spcAft>
-              <a:defRPr sz="1200">
-                <a:solidFill>
-                  <a:srgbClr val="0F172A"/>
-                </a:solidFill>
-              </a:defRPr>
-            </a:pPr>
-            <a:r>
-              <a:t>• Software Engineering: 'Build and launch a SaaS AI MVP in 4 weeks with authentication and billing.' (PRD, backend, frontend, testing).</a:t>
-            </a:r>
-          </a:p>
-          <a:p>
-            <a:pPr>
-              <a:spcAft>
-                <a:spcPts val="600"/>
-              </a:spcAft>
-              <a:defRPr sz="1200">
-                <a:solidFill>
-                  <a:srgbClr val="0F172A"/>
-                </a:solidFill>
-              </a:defRPr>
-            </a:pPr>
-            <a:r>
-              <a:t>• Exam Prep &amp; Certifications: 'Prepare for AWS Solutions Architect in 30 days.' (Study milestones, practice labs, revision).</a:t>
-            </a:r>
-          </a:p>
-          <a:p>
-            <a:pPr>
-              <a:spcAft>
-                <a:spcPts val="600"/>
-              </a:spcAft>
-              <a:defRPr sz="1200">
-                <a:solidFill>
-                  <a:srgbClr val="0F172A"/>
-                </a:solidFill>
-              </a:defRPr>
-            </a:pPr>
-            <a:r>
-              <a:t>• Events &amp; Hackathons: 'Organize a 2-day technical hackathon for 100 participants in 3 weeks.' (Venue, prizes, mentorship).</a:t>
-            </a:r>
-          </a:p>
-          <a:p>
-            <a:pPr>
-              <a:spcAft>
-                <a:spcPts val="600"/>
-              </a:spcAft>
-              <a:defRPr sz="1200">
-                <a:solidFill>
-                  <a:srgbClr val="0F172A"/>
-                </a:solidFill>
-              </a:defRPr>
-            </a:pPr>
-            <a:r>
-              <a:t>• Domestic &amp; Lifestyle: 'Renovate apartment with $5,000 budget' or 'Train for a half marathon in 10 weeks.'</a:t>
+              <a:t>• Granular Cost &amp; Time Attribution: Every single subtask receives localized cost, duration, and tool tags.</a:t>
             </a:r>
           </a:p>
         </p:txBody>
@@ -4519,6 +3728,14 @@
 <file path=ppt/slides/slide5.xml><?xml version="1.0" encoding="utf-8"?>
 <p:sld xmlns:a="http://schemas.openxmlformats.org/drawingml/2006/main" xmlns:p="http://schemas.openxmlformats.org/presentationml/2006/main" xmlns:r="http://schemas.openxmlformats.org/officeDocument/2006/relationships">
   <p:cSld>
+    <p:bg>
+      <p:bgPr>
+        <a:solidFill>
+          <a:srgbClr val="131314"/>
+        </a:solidFill>
+        <a:effectLst/>
+      </p:bgPr>
+    </p:bg>
     <p:spTree>
       <p:nvGrpSpPr>
         <p:cNvPr id="1" name=""/>
@@ -4528,57 +3745,14 @@
       <p:grpSpPr/>
       <p:sp>
         <p:nvSpPr>
-          <p:cNvPr id="2" name="Rectangle 1"/>
-          <p:cNvSpPr/>
+          <p:cNvPr id="2" name="TextBox 1"/>
+          <p:cNvSpPr txBox="1"/>
           <p:nvPr/>
         </p:nvSpPr>
         <p:spPr>
           <a:xfrm>
-            <a:off x="0" y="0"/>
-            <a:ext cx="12191695" cy="6858000"/>
-          </a:xfrm>
-          <a:prstGeom prst="rect">
-            <a:avLst/>
-          </a:prstGeom>
-          <a:solidFill>
-            <a:srgbClr val="FAFAFC"/>
-          </a:solidFill>
-          <a:ln>
-            <a:noFill/>
-          </a:ln>
-        </p:spPr>
-        <p:style>
-          <a:lnRef idx="1">
-            <a:schemeClr val="accent1"/>
-          </a:lnRef>
-          <a:fillRef idx="3">
-            <a:schemeClr val="accent1"/>
-          </a:fillRef>
-          <a:effectRef idx="2">
-            <a:schemeClr val="accent1"/>
-          </a:effectRef>
-          <a:fontRef idx="minor">
-            <a:schemeClr val="lt1"/>
-          </a:fontRef>
-        </p:style>
-        <p:txBody>
-          <a:bodyPr rtlCol="0" anchor="ctr"/>
-          <a:lstStyle/>
-          <a:p>
-            <a:pPr algn="ctr"/>
-          </a:p>
-        </p:txBody>
-      </p:sp>
-      <p:sp>
-        <p:nvSpPr>
-          <p:cNvPr id="3" name="TextBox 2"/>
-          <p:cNvSpPr txBox="1"/>
-          <p:nvPr/>
-        </p:nvSpPr>
-        <p:spPr>
-          <a:xfrm>
-            <a:off x="731520" y="457200"/>
-            <a:ext cx="10698480" cy="365760"/>
+            <a:off x="731520" y="731520"/>
+            <a:ext cx="10698480" cy="1097280"/>
           </a:xfrm>
           <a:prstGeom prst="rect">
             <a:avLst/>
@@ -4592,28 +3766,40 @@
           <a:lstStyle/>
           <a:p>
             <a:pPr>
-              <a:defRPr sz="1100" b="1">
-                <a:solidFill>
-                  <a:srgbClr val="DC2626"/>
+              <a:defRPr sz="3600" b="1">
+                <a:solidFill>
+                  <a:srgbClr val="4285F4"/>
                 </a:solidFill>
               </a:defRPr>
             </a:pPr>
             <a:r>
-              <a:t>04 / BENCHMARKS &amp; COMPLIANCE</a:t>
-            </a:r>
-          </a:p>
-        </p:txBody>
-      </p:sp>
-      <p:sp>
-        <p:nvSpPr>
-          <p:cNvPr id="4" name="TextBox 3"/>
+              <a:t>Key Deliverables, UI Excellence &amp; Impact</a:t>
+            </a:r>
+          </a:p>
+          <a:p>
+            <a:pPr>
+              <a:defRPr sz="1800">
+                <a:solidFill>
+                  <a:srgbClr val="8E918F"/>
+                </a:solidFill>
+              </a:defRPr>
+            </a:pPr>
+            <a:r>
+              <a:t>Complete Full-Stack Implementation Ready for Production</a:t>
+            </a:r>
+          </a:p>
+        </p:txBody>
+      </p:sp>
+      <p:sp>
+        <p:nvSpPr>
+          <p:cNvPr id="3" name="TextBox 2"/>
           <p:cNvSpPr txBox="1"/>
           <p:nvPr/>
         </p:nvSpPr>
         <p:spPr>
           <a:xfrm>
-            <a:off x="731520" y="731520"/>
-            <a:ext cx="10698480" cy="731520"/>
+            <a:off x="731520" y="2011680"/>
+            <a:ext cx="10698480" cy="4114800"/>
           </a:xfrm>
           <a:prstGeom prst="rect">
             <a:avLst/>
@@ -4625,148 +3811,80 @@
             <a:spAutoFit/>
           </a:bodyPr>
           <a:lstStyle/>
-          <a:p>
-            <a:pPr>
-              <a:defRPr sz="2600" b="1">
-                <a:solidFill>
-                  <a:srgbClr val="0F172A"/>
-                </a:solidFill>
-              </a:defRPr>
-            </a:pPr>
-            <a:r>
-              <a:t>Test Coverage, Technology Stack &amp; Contest Compliance</a:t>
-            </a:r>
-          </a:p>
-        </p:txBody>
-      </p:sp>
-      <p:sp>
-        <p:nvSpPr>
-          <p:cNvPr id="5" name="Rounded Rectangle 4"/>
-          <p:cNvSpPr/>
-          <p:nvPr/>
-        </p:nvSpPr>
-        <p:spPr>
-          <a:xfrm>
-            <a:off x="731520" y="1645920"/>
-            <a:ext cx="10698480" cy="4389120"/>
-          </a:xfrm>
-          <a:prstGeom prst="roundRect">
-            <a:avLst/>
-          </a:prstGeom>
-          <a:solidFill>
-            <a:srgbClr val="FFFFFF"/>
-          </a:solidFill>
-          <a:ln>
-            <a:solidFill>
-              <a:srgbClr val="E2E8F0"/>
-            </a:solidFill>
-          </a:ln>
-        </p:spPr>
-        <p:style>
-          <a:lnRef idx="1">
-            <a:schemeClr val="accent1"/>
-          </a:lnRef>
-          <a:fillRef idx="3">
-            <a:schemeClr val="accent1"/>
-          </a:fillRef>
-          <a:effectRef idx="2">
-            <a:schemeClr val="accent1"/>
-          </a:effectRef>
-          <a:fontRef idx="minor">
-            <a:schemeClr val="lt1"/>
-          </a:fontRef>
-        </p:style>
-        <p:txBody>
-          <a:bodyPr rtlCol="0" anchor="ctr" wrap="square"/>
-          <a:lstStyle/>
-          <a:p>
-            <a:pPr algn="ctr">
-              <a:spcAft>
-                <a:spcPts val="1200"/>
-              </a:spcAft>
-              <a:defRPr sz="1800" b="1">
-                <a:solidFill>
-                  <a:srgbClr val="DC2626"/>
-                </a:solidFill>
-              </a:defRPr>
-            </a:pPr>
-            <a:r>
-              <a:t>🎯 Benchmark Verification &amp; Compliance Matrix</a:t>
-            </a:r>
-          </a:p>
+          <a:p/>
           <a:p>
             <a:pPr>
               <a:spcAft>
-                <a:spcPts val="800"/>
+                <a:spcPts val="1800"/>
               </a:spcAft>
-              <a:defRPr sz="1300">
-                <a:solidFill>
-                  <a:srgbClr val="0F172A"/>
+              <a:defRPr sz="2000">
+                <a:solidFill>
+                  <a:srgbClr val="F0F4F9"/>
                 </a:solidFill>
               </a:defRPr>
             </a:pPr>
             <a:r>
-              <a:t>✔ 100% Automated Test Suite: 6 automated unit tests validating intent extraction, feasibility scoring, arbitrary task decomposition, critical path derivation, risk safeguards, and end-to-end plan generation.</a:t>
+              <a:t>• Google Gemini Aesthetics: Clean dark/light theme, floating pill composer, and real-time execution trace drawer.</a:t>
             </a:r>
           </a:p>
           <a:p>
             <a:pPr>
               <a:spcAft>
-                <a:spcPts val="800"/>
+                <a:spcPts val="1800"/>
               </a:spcAft>
-              <a:defRPr sz="1300">
-                <a:solidFill>
-                  <a:srgbClr val="0F172A"/>
+              <a:defRPr sz="2000">
+                <a:solidFill>
+                  <a:srgbClr val="F0F4F9"/>
                 </a:solidFill>
               </a:defRPr>
             </a:pPr>
             <a:r>
-              <a:t>✔ Strict Agentic Behavior: Demonstrates true Plan -&gt; Act -&gt; Observe -&gt; Respond workflow with continuous scratchpad telemetry (no single-shot prompt hacks).</a:t>
+              <a:t>• Interactive Task Workspace: Check off completed subtasks, view dependencies, and inspect risk mitigations.</a:t>
             </a:r>
           </a:p>
           <a:p>
             <a:pPr>
               <a:spcAft>
-                <a:spcPts val="800"/>
+                <a:spcPts val="1800"/>
               </a:spcAft>
-              <a:defRPr sz="1300">
-                <a:solidFill>
-                  <a:srgbClr val="0F172A"/>
+              <a:defRPr sz="2000">
+                <a:solidFill>
+                  <a:srgbClr val="F0F4F9"/>
                 </a:solidFill>
               </a:defRPr>
             </a:pPr>
             <a:r>
-              <a:t>✔ Free-Tier &amp; Zero-Key Compliance: Supports Google Gemini API (gemini-1.5-flash) and features a built-in offline simulator engine so judges can run it without API keys.</a:t>
+              <a:t>• Follow-Up Chat Refinement: Ask the agent to reduce expenses, shorten timelines, or explain tasks dynamically.</a:t>
             </a:r>
           </a:p>
           <a:p>
             <a:pPr>
               <a:spcAft>
-                <a:spcPts val="800"/>
+                <a:spcPts val="1800"/>
               </a:spcAft>
-              <a:defRPr sz="1300">
-                <a:solidFill>
-                  <a:srgbClr val="0F172A"/>
+              <a:defRPr sz="2000">
+                <a:solidFill>
+                  <a:srgbClr val="F0F4F9"/>
                 </a:solidFill>
               </a:defRPr>
             </a:pPr>
             <a:r>
-              <a:t>✔ Ultra-Smooth Red &amp; White Gemini UI: Minimalist, clean user interface styled with crimson red accents and floating suggestion chips.</a:t>
+              <a:t>• Multi-Format Exports: Instant export to Markdown (.md), structured JSON (.json), and printable views.</a:t>
             </a:r>
           </a:p>
           <a:p>
             <a:pPr>
               <a:spcAft>
-                <a:spcPts val="800"/>
+                <a:spcPts val="1800"/>
               </a:spcAft>
-              <a:defRPr sz="1300">
-                <a:solidFill>
-                  <a:srgbClr val="0F172A"/>
+              <a:defRPr sz="2000">
+                <a:solidFill>
+                  <a:srgbClr val="F0F4F9"/>
                 </a:solidFill>
               </a:defRPr>
             </a:pPr>
             <a:r>
-              <a:t>✔ Audit Trail: Structured plan export into JSON guarantees every generated plan has a unique Plan ID (PLAN-2026-...) for verifiable execution.</a:t>
+              <a:t>• 100% Autonomous Out-of-the-Box: Zero paid API key dependency, with optional Google Gemini 2.5 Flash integration.</a:t>
             </a:r>
           </a:p>
         </p:txBody>

</xml_diff>